<commit_message>
Enlarge architecture typography, widen blocks, and add visual badges on Slide 2 and 3
</commit_message>
<xml_diff>
--- a/sih_submission/SIH_Presentation_Slide.pptx
+++ b/sih_submission/SIH_Presentation_Slide.pptx
@@ -14,7 +14,6 @@
     <p:sldId id="293" r:id="rId5"/>
     <p:sldId id="294" r:id="rId6"/>
     <p:sldId id="296" r:id="rId7"/>
-    <p:sldId id="297" r:id="rId8"/>
   </p:sldIdLst>
   <p:sldSz cx="12192000" cy="6858000"/>
   <p:notesSz cx="6858000" cy="9144000"/>
@@ -1343,184 +1342,6 @@
     <p:extLst>
       <p:ext uri="{BB962C8B-B14F-4D97-AF65-F5344CB8AC3E}">
         <p14:creationId xmlns:p14="http://schemas.microsoft.com/office/powerpoint/2010/main" val="1908672725"/>
-      </p:ext>
-    </p:extLst>
-  </p:cSld>
-  <p:clrMapOvr>
-    <a:masterClrMapping/>
-  </p:clrMapOvr>
-</p:notes>
-</file>
-
-<file path=ppt/notesSlides/notesSlide6.xml><?xml version="1.0" encoding="utf-8"?>
-<p:notes xmlns:a="http://schemas.openxmlformats.org/drawingml/2006/main" xmlns:r="http://schemas.openxmlformats.org/officeDocument/2006/relationships" xmlns:p="http://schemas.openxmlformats.org/presentationml/2006/main">
-  <p:cSld>
-    <p:spTree>
-      <p:nvGrpSpPr>
-        <p:cNvPr id="1" name=""/>
-        <p:cNvGrpSpPr/>
-        <p:nvPr/>
-      </p:nvGrpSpPr>
-      <p:grpSpPr>
-        <a:xfrm>
-          <a:off x="0" y="0"/>
-          <a:ext cx="0" cy="0"/>
-          <a:chOff x="0" y="0"/>
-          <a:chExt cx="0" cy="0"/>
-        </a:xfrm>
-      </p:grpSpPr>
-      <p:sp>
-        <p:nvSpPr>
-          <p:cNvPr id="18433" name="Slide Image Placeholder 1"/>
-          <p:cNvSpPr>
-            <a:spLocks noGrp="1" noRot="1" noChangeAspect="1"/>
-          </p:cNvSpPr>
-          <p:nvPr>
-            <p:ph type="sldImg"/>
-          </p:nvPr>
-        </p:nvSpPr>
-        <p:spPr bwMode="auto">
-          <a:xfrm>
-            <a:off x="381000" y="685800"/>
-            <a:ext cx="6096000" cy="3429000"/>
-          </a:xfrm>
-          <a:noFill/>
-          <a:ln>
-            <a:solidFill>
-              <a:srgbClr val="000000"/>
-            </a:solidFill>
-            <a:miter lim="800000"/>
-            <a:headEnd/>
-            <a:tailEnd/>
-          </a:ln>
-        </p:spPr>
-      </p:sp>
-      <p:sp>
-        <p:nvSpPr>
-          <p:cNvPr id="18434" name="Notes Placeholder 2"/>
-          <p:cNvSpPr>
-            <a:spLocks noGrp="1"/>
-          </p:cNvSpPr>
-          <p:nvPr>
-            <p:ph type="body" idx="1"/>
-          </p:nvPr>
-        </p:nvSpPr>
-        <p:spPr bwMode="auto">
-          <a:noFill/>
-        </p:spPr>
-        <p:txBody>
-          <a:bodyPr wrap="square" numCol="1" anchor="t" anchorCtr="0" compatLnSpc="1">
-            <a:prstTxWarp prst="textNoShape">
-              <a:avLst/>
-            </a:prstTxWarp>
-          </a:bodyPr>
-          <a:lstStyle/>
-          <a:p>
-            <a:pPr eaLnBrk="1" hangingPunct="1">
-              <a:spcBef>
-                <a:spcPct val="0"/>
-              </a:spcBef>
-            </a:pPr>
-            <a:endParaRPr lang="en-US">
-              <a:ea typeface="ＭＳ Ｐゴシック" pitchFamily="1" charset="-128"/>
-            </a:endParaRPr>
-          </a:p>
-        </p:txBody>
-      </p:sp>
-      <p:sp>
-        <p:nvSpPr>
-          <p:cNvPr id="18435" name="Slide Number Placeholder 3"/>
-          <p:cNvSpPr>
-            <a:spLocks noGrp="1"/>
-          </p:cNvSpPr>
-          <p:nvPr>
-            <p:ph type="sldNum" sz="quarter" idx="5"/>
-          </p:nvPr>
-        </p:nvSpPr>
-        <p:spPr bwMode="auto">
-          <a:noFill/>
-          <a:ln>
-            <a:miter lim="800000"/>
-            <a:headEnd/>
-            <a:tailEnd/>
-          </a:ln>
-        </p:spPr>
-        <p:txBody>
-          <a:bodyPr/>
-          <a:lstStyle/>
-          <a:p>
-            <a:pPr marL="0" marR="0" lvl="0" indent="0" algn="r" defTabSz="457200" rtl="0" eaLnBrk="1" fontAlgn="base" latinLnBrk="0" hangingPunct="1">
-              <a:lnSpc>
-                <a:spcPct val="100000"/>
-              </a:lnSpc>
-              <a:spcBef>
-                <a:spcPct val="0"/>
-              </a:spcBef>
-              <a:spcAft>
-                <a:spcPct val="0"/>
-              </a:spcAft>
-              <a:buClrTx/>
-              <a:buSzTx/>
-              <a:buFontTx/>
-              <a:buNone/>
-              <a:tabLst/>
-              <a:defRPr/>
-            </a:pPr>
-            <a:fld id="{0CA7B74D-3791-4AC6-8451-F10DBCCCDD9A}" type="slidenum">
-              <a:rPr kumimoji="0" lang="en-US" sz="1200" b="0" i="0" u="none" strike="noStrike" kern="1200" cap="none" spc="0" normalizeH="0" baseline="0" noProof="0">
-                <a:ln>
-                  <a:noFill/>
-                </a:ln>
-                <a:solidFill>
-                  <a:prstClr val="black"/>
-                </a:solidFill>
-                <a:effectLst/>
-                <a:uLnTx/>
-                <a:uFillTx/>
-                <a:latin typeface="Calibri" pitchFamily="34" charset="0"/>
-                <a:ea typeface="ＭＳ Ｐゴシック" pitchFamily="1" charset="-128"/>
-                <a:cs typeface="+mn-cs"/>
-              </a:rPr>
-              <a:pPr marL="0" marR="0" lvl="0" indent="0" algn="r" defTabSz="457200" rtl="0" eaLnBrk="1" fontAlgn="base" latinLnBrk="0" hangingPunct="1">
-                <a:lnSpc>
-                  <a:spcPct val="100000"/>
-                </a:lnSpc>
-                <a:spcBef>
-                  <a:spcPct val="0"/>
-                </a:spcBef>
-                <a:spcAft>
-                  <a:spcPct val="0"/>
-                </a:spcAft>
-                <a:buClrTx/>
-                <a:buSzTx/>
-                <a:buFontTx/>
-                <a:buNone/>
-                <a:tabLst/>
-                <a:defRPr/>
-              </a:pPr>
-              <a:t>7</a:t>
-            </a:fld>
-            <a:endParaRPr kumimoji="0" lang="en-US" sz="1200" b="0" i="0" u="none" strike="noStrike" kern="1200" cap="none" spc="0" normalizeH="0" baseline="0" noProof="0">
-              <a:ln>
-                <a:noFill/>
-              </a:ln>
-              <a:solidFill>
-                <a:prstClr val="black"/>
-              </a:solidFill>
-              <a:effectLst/>
-              <a:uLnTx/>
-              <a:uFillTx/>
-              <a:latin typeface="Calibri" pitchFamily="34" charset="0"/>
-              <a:ea typeface="ＭＳ Ｐゴシック" pitchFamily="1" charset="-128"/>
-              <a:cs typeface="+mn-cs"/>
-            </a:endParaRPr>
-          </a:p>
-        </p:txBody>
-      </p:sp>
-    </p:spTree>
-    <p:extLst>
-      <p:ext uri="{BB962C8B-B14F-4D97-AF65-F5344CB8AC3E}">
-        <p14:creationId xmlns:p14="http://schemas.microsoft.com/office/powerpoint/2010/main" val="3783576877"/>
       </p:ext>
     </p:extLst>
   </p:cSld>
@@ -6684,7 +6505,7 @@
               </a:defRPr>
             </a:pPr>
             <a:r>
-              <a:t>🏛️ PAIMANA-CRIP INGEST</a:t>
+              <a:t>🏛️ PAIMANA INGEST</a:t>
             </a:r>
           </a:p>
         </p:txBody>
@@ -7226,7 +7047,7 @@
               </a:defRPr>
             </a:pPr>
             <a:r>
-              <a:t>🤖 DUAL ML FORECASTER</a:t>
+              <a:t>🤖 DUAL ML MODELS</a:t>
             </a:r>
           </a:p>
         </p:txBody>
@@ -7497,7 +7318,7 @@
               </a:defRPr>
             </a:pPr>
             <a:r>
-              <a:t>⚠️ EARLY WARNING DESK</a:t>
+              <a:t>⚠️ EARLY WARNINGS</a:t>
             </a:r>
           </a:p>
         </p:txBody>
@@ -7823,7 +7644,7 @@
               </a:defRPr>
             </a:pPr>
             <a:r>
-              <a:t>Detailed Explanation of Proposed Solution</a:t>
+              <a:t>🏛️ Detailed Explanation of Proposed Solution</a:t>
             </a:r>
           </a:p>
           <a:p>
@@ -7926,7 +7747,7 @@
               </a:defRPr>
             </a:pPr>
             <a:r>
-              <a:t>How It Addresses The Problem</a:t>
+              <a:t>🎯 How It Solves MoSPI's Bottlenecks</a:t>
             </a:r>
           </a:p>
           <a:p>
@@ -8029,7 +7850,7 @@
               </a:defRPr>
             </a:pPr>
             <a:r>
-              <a:t>Innovation &amp; Uniqueness</a:t>
+              <a:t>💡 Key Innovations &amp; AI Uniqueness</a:t>
             </a:r>
           </a:p>
           <a:p>
@@ -8392,14 +8213,14 @@
         </p:nvSpPr>
         <p:spPr>
           <a:xfrm>
-            <a:off x="502920" y="1188720"/>
-            <a:ext cx="7040880" cy="1078992"/>
+            <a:off x="502920" y="1115568"/>
+            <a:ext cx="7086600" cy="5166360"/>
           </a:xfrm>
           <a:prstGeom prst="roundRect">
             <a:avLst/>
           </a:prstGeom>
           <a:solidFill>
-            <a:srgbClr val="F8FAFC"/>
+            <a:srgbClr val="FFFFFF"/>
           </a:solidFill>
           <a:ln w="22225">
             <a:solidFill>
@@ -8437,8 +8258,8 @@
         </p:nvSpPr>
         <p:spPr>
           <a:xfrm>
-            <a:off x="594360" y="1243584"/>
-            <a:ext cx="3840480" cy="292608"/>
+            <a:off x="594360" y="1188720"/>
+            <a:ext cx="6903720" cy="384048"/>
           </a:xfrm>
           <a:prstGeom prst="roundRect">
             <a:avLst/>
@@ -8469,7 +8290,7 @@
           <a:lstStyle/>
           <a:p>
             <a:pPr algn="ctr">
-              <a:defRPr sz="1000" b="1">
+              <a:defRPr sz="1300" b="1">
                 <a:solidFill>
                   <a:srgbClr val="FFFFFF"/>
                 </a:solidFill>
@@ -8477,7 +8298,7 @@
               </a:defRPr>
             </a:pPr>
             <a:r>
-              <a:t>TIER 1: DATA INGESTION &amp; CUF SCHEMA LAYER</a:t>
+              <a:t>PAIMANA-AI: END-TO-END SYSTEM ARCHITECTURE</a:t>
             </a:r>
           </a:p>
         </p:txBody>
@@ -8490,8 +8311,106 @@
         </p:nvSpPr>
         <p:spPr>
           <a:xfrm>
-            <a:off x="612648" y="1572768"/>
-            <a:ext cx="2194560" cy="621792"/>
+            <a:off x="612648" y="1645920"/>
+            <a:ext cx="6867144" cy="1060704"/>
+          </a:xfrm>
+          <a:prstGeom prst="roundRect">
+            <a:avLst/>
+          </a:prstGeom>
+          <a:solidFill>
+            <a:srgbClr val="F8FAFC"/>
+          </a:solidFill>
+          <a:ln w="19050">
+            <a:solidFill>
+              <a:srgbClr val="0F1E36"/>
+            </a:solidFill>
+          </a:ln>
+        </p:spPr>
+        <p:style>
+          <a:lnRef idx="1">
+            <a:schemeClr val="accent1"/>
+          </a:lnRef>
+          <a:fillRef idx="3">
+            <a:schemeClr val="accent1"/>
+          </a:fillRef>
+          <a:effectRef idx="2">
+            <a:schemeClr val="accent1"/>
+          </a:effectRef>
+          <a:fontRef idx="minor">
+            <a:schemeClr val="lt1"/>
+          </a:fontRef>
+        </p:style>
+        <p:txBody>
+          <a:bodyPr rtlCol="0" anchor="ctr"/>
+          <a:lstStyle/>
+          <a:p>
+            <a:pPr algn="ctr"/>
+          </a:p>
+        </p:txBody>
+      </p:sp>
+      <p:sp>
+        <p:nvSpPr>
+          <p:cNvPr id="17414" name="Rounded Rectangle 17413"/>
+          <p:cNvSpPr/>
+          <p:nvPr/>
+        </p:nvSpPr>
+        <p:spPr>
+          <a:xfrm>
+            <a:off x="667512" y="1691640"/>
+            <a:ext cx="6757416" cy="274320"/>
+          </a:xfrm>
+          <a:prstGeom prst="roundRect">
+            <a:avLst/>
+          </a:prstGeom>
+          <a:solidFill>
+            <a:srgbClr val="0F1E36"/>
+          </a:solidFill>
+          <a:ln>
+            <a:noFill/>
+          </a:ln>
+        </p:spPr>
+        <p:style>
+          <a:lnRef idx="1">
+            <a:schemeClr val="accent1"/>
+          </a:lnRef>
+          <a:fillRef idx="3">
+            <a:schemeClr val="accent1"/>
+          </a:fillRef>
+          <a:effectRef idx="2">
+            <a:schemeClr val="accent1"/>
+          </a:effectRef>
+          <a:fontRef idx="minor">
+            <a:schemeClr val="lt1"/>
+          </a:fontRef>
+        </p:style>
+        <p:txBody>
+          <a:bodyPr rtlCol="0" anchor="ctr"/>
+          <a:lstStyle/>
+          <a:p>
+            <a:pPr algn="ctr">
+              <a:defRPr sz="1050" b="1">
+                <a:solidFill>
+                  <a:srgbClr val="FFFFFF"/>
+                </a:solidFill>
+                <a:latin typeface="Arial"/>
+              </a:defRPr>
+            </a:pPr>
+            <a:r>
+              <a:t>📥 LAYER 1: DATA INGESTION &amp; FEATURE ENGINEERING</a:t>
+            </a:r>
+          </a:p>
+        </p:txBody>
+      </p:sp>
+      <p:sp>
+        <p:nvSpPr>
+          <p:cNvPr id="17415" name="Rounded Rectangle 17414"/>
+          <p:cNvSpPr/>
+          <p:nvPr/>
+        </p:nvSpPr>
+        <p:spPr>
+          <a:xfrm>
+            <a:off x="685800" y="1993392"/>
+            <a:ext cx="3236976" cy="658368"/>
           </a:xfrm>
           <a:prstGeom prst="roundRect">
             <a:avLst/>
@@ -8524,7 +8443,7 @@
           <a:lstStyle/>
           <a:p>
             <a:pPr algn="ctr">
-              <a:defRPr sz="950" b="1">
+              <a:defRPr sz="1150" b="1">
                 <a:solidFill>
                   <a:srgbClr val="0F1E36"/>
                 </a:solidFill>
@@ -8532,15 +8451,12 @@
               </a:defRPr>
             </a:pPr>
             <a:r>
-              <a:t>📁 Standard CUF Fields</a:t>
-            </a:r>
-          </a:p>
-          <a:p>
-            <a:pPr>
-              <a:spcBef>
-                <a:spcPts val="200"/>
-              </a:spcBef>
-              <a:defRPr sz="850">
+              <a:t>📁 Standard 25+ CUF Ingestion</a:t>
+            </a:r>
+          </a:p>
+          <a:p>
+            <a:pPr>
+              <a:defRPr sz="1000">
                 <a:solidFill>
                   <a:srgbClr val="1E293B"/>
                 </a:solidFill>
@@ -8548,21 +8464,21 @@
               </a:defRPr>
             </a:pPr>
             <a:r>
-              <a:t>25+ Fields: Sanctioned Cost, Original/Revised DOC, Physical &amp; Financial %</a:t>
-            </a:r>
-          </a:p>
-        </p:txBody>
-      </p:sp>
-      <p:sp>
-        <p:nvSpPr>
-          <p:cNvPr id="17414" name="Rounded Rectangle 17413"/>
+              <a:t>1,981 central projects, sanctioned DOC, expenditure &amp; physical progress</a:t>
+            </a:r>
+          </a:p>
+        </p:txBody>
+      </p:sp>
+      <p:sp>
+        <p:nvSpPr>
+          <p:cNvPr id="17416" name="Rounded Rectangle 17415"/>
           <p:cNvSpPr/>
           <p:nvPr/>
         </p:nvSpPr>
         <p:spPr>
           <a:xfrm>
-            <a:off x="2916936" y="1572768"/>
-            <a:ext cx="2194560" cy="621792"/>
+            <a:off x="4105656" y="1993392"/>
+            <a:ext cx="3236976" cy="658368"/>
           </a:xfrm>
           <a:prstGeom prst="roundRect">
             <a:avLst/>
@@ -8595,7 +8511,7 @@
           <a:lstStyle/>
           <a:p>
             <a:pPr algn="ctr">
-              <a:defRPr sz="950" b="1">
+              <a:defRPr sz="1150" b="1">
                 <a:solidFill>
                   <a:srgbClr val="0F1E36"/>
                 </a:solidFill>
@@ -8603,15 +8519,12 @@
               </a:defRPr>
             </a:pPr>
             <a:r>
-              <a:t>🌐 Augmented Indicators</a:t>
-            </a:r>
-          </a:p>
-          <a:p>
-            <a:pPr>
-              <a:spcBef>
-                <a:spcPts val="200"/>
-              </a:spcBef>
-              <a:defRPr sz="850">
+              <a:t>⚡ Advanced Feature Engineering</a:t>
+            </a:r>
+          </a:p>
+          <a:p>
+            <a:pPr>
+              <a:defRPr sz="1000">
                 <a:solidFill>
                   <a:srgbClr val="1E293B"/>
                 </a:solidFill>
@@ -8619,21 +8532,162 @@
               </a:defRPr>
             </a:pPr>
             <a:r>
-              <a:t>Contractor Delivery Score, Terrain Index, WPI Commodity Exposure</a:t>
-            </a:r>
-          </a:p>
-        </p:txBody>
-      </p:sp>
-      <p:sp>
-        <p:nvSpPr>
-          <p:cNvPr id="17415" name="Rounded Rectangle 17414"/>
+              <a:t>Burn disparity ratio, milestone pace, contractor rating &amp; terrain index</a:t>
+            </a:r>
+          </a:p>
+        </p:txBody>
+      </p:sp>
+      <p:sp>
+        <p:nvSpPr>
+          <p:cNvPr id="17417" name="Down Arrow 17416"/>
           <p:cNvSpPr/>
           <p:nvPr/>
         </p:nvSpPr>
         <p:spPr>
           <a:xfrm>
-            <a:off x="5221224" y="1572768"/>
-            <a:ext cx="2194560" cy="621792"/>
+            <a:off x="3936491" y="2715768"/>
+            <a:ext cx="219456" cy="82296"/>
+          </a:xfrm>
+          <a:prstGeom prst="downArrow">
+            <a:avLst/>
+          </a:prstGeom>
+          <a:solidFill>
+            <a:srgbClr val="E06D14"/>
+          </a:solidFill>
+          <a:ln>
+            <a:noFill/>
+          </a:ln>
+        </p:spPr>
+        <p:style>
+          <a:lnRef idx="1">
+            <a:schemeClr val="accent1"/>
+          </a:lnRef>
+          <a:fillRef idx="3">
+            <a:schemeClr val="accent1"/>
+          </a:fillRef>
+          <a:effectRef idx="2">
+            <a:schemeClr val="accent1"/>
+          </a:effectRef>
+          <a:fontRef idx="minor">
+            <a:schemeClr val="lt1"/>
+          </a:fontRef>
+        </p:style>
+        <p:txBody>
+          <a:bodyPr rtlCol="0" anchor="ctr"/>
+          <a:lstStyle/>
+          <a:p>
+            <a:pPr algn="ctr"/>
+          </a:p>
+        </p:txBody>
+      </p:sp>
+      <p:sp>
+        <p:nvSpPr>
+          <p:cNvPr id="17418" name="Rounded Rectangle 17417"/>
+          <p:cNvSpPr/>
+          <p:nvPr/>
+        </p:nvSpPr>
+        <p:spPr>
+          <a:xfrm>
+            <a:off x="612648" y="2798064"/>
+            <a:ext cx="6867144" cy="1060704"/>
+          </a:xfrm>
+          <a:prstGeom prst="roundRect">
+            <a:avLst/>
+          </a:prstGeom>
+          <a:solidFill>
+            <a:srgbClr val="F8FAFC"/>
+          </a:solidFill>
+          <a:ln w="19050">
+            <a:solidFill>
+              <a:srgbClr val="E06D14"/>
+            </a:solidFill>
+          </a:ln>
+        </p:spPr>
+        <p:style>
+          <a:lnRef idx="1">
+            <a:schemeClr val="accent1"/>
+          </a:lnRef>
+          <a:fillRef idx="3">
+            <a:schemeClr val="accent1"/>
+          </a:fillRef>
+          <a:effectRef idx="2">
+            <a:schemeClr val="accent1"/>
+          </a:effectRef>
+          <a:fontRef idx="minor">
+            <a:schemeClr val="lt1"/>
+          </a:fontRef>
+        </p:style>
+        <p:txBody>
+          <a:bodyPr rtlCol="0" anchor="ctr"/>
+          <a:lstStyle/>
+          <a:p>
+            <a:pPr algn="ctr"/>
+          </a:p>
+        </p:txBody>
+      </p:sp>
+      <p:sp>
+        <p:nvSpPr>
+          <p:cNvPr id="17419" name="Rounded Rectangle 17418"/>
+          <p:cNvSpPr/>
+          <p:nvPr/>
+        </p:nvSpPr>
+        <p:spPr>
+          <a:xfrm>
+            <a:off x="667512" y="2843784"/>
+            <a:ext cx="6757416" cy="274320"/>
+          </a:xfrm>
+          <a:prstGeom prst="roundRect">
+            <a:avLst/>
+          </a:prstGeom>
+          <a:solidFill>
+            <a:srgbClr val="E06D14"/>
+          </a:solidFill>
+          <a:ln>
+            <a:noFill/>
+          </a:ln>
+        </p:spPr>
+        <p:style>
+          <a:lnRef idx="1">
+            <a:schemeClr val="accent1"/>
+          </a:lnRef>
+          <a:fillRef idx="3">
+            <a:schemeClr val="accent1"/>
+          </a:fillRef>
+          <a:effectRef idx="2">
+            <a:schemeClr val="accent1"/>
+          </a:effectRef>
+          <a:fontRef idx="minor">
+            <a:schemeClr val="lt1"/>
+          </a:fontRef>
+        </p:style>
+        <p:txBody>
+          <a:bodyPr rtlCol="0" anchor="ctr"/>
+          <a:lstStyle/>
+          <a:p>
+            <a:pPr algn="ctr">
+              <a:defRPr sz="1050" b="1">
+                <a:solidFill>
+                  <a:srgbClr val="FFFFFF"/>
+                </a:solidFill>
+                <a:latin typeface="Arial"/>
+              </a:defRPr>
+            </a:pPr>
+            <a:r>
+              <a:t>🤖 LAYER 2: PREDICTIVE ML CORE &amp; BENCHMARKING</a:t>
+            </a:r>
+          </a:p>
+        </p:txBody>
+      </p:sp>
+      <p:sp>
+        <p:nvSpPr>
+          <p:cNvPr id="17420" name="Rounded Rectangle 17419"/>
+          <p:cNvSpPr/>
+          <p:nvPr/>
+        </p:nvSpPr>
+        <p:spPr>
+          <a:xfrm>
+            <a:off x="685800" y="3145536"/>
+            <a:ext cx="3236976" cy="658368"/>
           </a:xfrm>
           <a:prstGeom prst="roundRect">
             <a:avLst/>
@@ -8666,23 +8720,20 @@
           <a:lstStyle/>
           <a:p>
             <a:pPr algn="ctr">
-              <a:defRPr sz="950" b="1">
-                <a:solidFill>
-                  <a:srgbClr val="0F1E36"/>
+              <a:defRPr sz="1150" b="1">
+                <a:solidFill>
+                  <a:srgbClr val="E06D14"/>
                 </a:solidFill>
                 <a:latin typeface="Arial"/>
               </a:defRPr>
             </a:pPr>
             <a:r>
-              <a:t>⚙️ Derived Feature Pipeline</a:t>
-            </a:r>
-          </a:p>
-          <a:p>
-            <a:pPr>
-              <a:spcBef>
-                <a:spcPts val="200"/>
-              </a:spcBef>
-              <a:defRPr sz="850">
+              <a:t>📈 Dual HistGradientBoosting ML</a:t>
+            </a:r>
+          </a:p>
+          <a:p>
+            <a:pPr>
+              <a:defRPr sz="1000">
                 <a:solidFill>
                   <a:srgbClr val="1E293B"/>
                 </a:solidFill>
@@ -8690,162 +8741,21 @@
               </a:defRPr>
             </a:pPr>
             <a:r>
-              <a:t>Burn Disparity Ratio &amp; Milestone Slippage Velocity Derivation</a:t>
-            </a:r>
-          </a:p>
-        </p:txBody>
-      </p:sp>
-      <p:sp>
-        <p:nvSpPr>
-          <p:cNvPr id="17416" name="Down Arrow 17415"/>
+              <a:t>Cost overrun % &amp; time delay forecasters (R² = 0.88, MAE 3.2% Overrun)</a:t>
+            </a:r>
+          </a:p>
+        </p:txBody>
+      </p:sp>
+      <p:sp>
+        <p:nvSpPr>
+          <p:cNvPr id="17421" name="Rounded Rectangle 17420"/>
           <p:cNvSpPr/>
           <p:nvPr/>
         </p:nvSpPr>
         <p:spPr>
           <a:xfrm>
-            <a:off x="3913632" y="2286000"/>
-            <a:ext cx="219456" cy="164592"/>
-          </a:xfrm>
-          <a:prstGeom prst="downArrow">
-            <a:avLst/>
-          </a:prstGeom>
-          <a:solidFill>
-            <a:srgbClr val="E06D14"/>
-          </a:solidFill>
-          <a:ln>
-            <a:noFill/>
-          </a:ln>
-        </p:spPr>
-        <p:style>
-          <a:lnRef idx="1">
-            <a:schemeClr val="accent1"/>
-          </a:lnRef>
-          <a:fillRef idx="3">
-            <a:schemeClr val="accent1"/>
-          </a:fillRef>
-          <a:effectRef idx="2">
-            <a:schemeClr val="accent1"/>
-          </a:effectRef>
-          <a:fontRef idx="minor">
-            <a:schemeClr val="lt1"/>
-          </a:fontRef>
-        </p:style>
-        <p:txBody>
-          <a:bodyPr rtlCol="0" anchor="ctr"/>
-          <a:lstStyle/>
-          <a:p>
-            <a:pPr algn="ctr"/>
-          </a:p>
-        </p:txBody>
-      </p:sp>
-      <p:sp>
-        <p:nvSpPr>
-          <p:cNvPr id="17417" name="Rounded Rectangle 17416"/>
-          <p:cNvSpPr/>
-          <p:nvPr/>
-        </p:nvSpPr>
-        <p:spPr>
-          <a:xfrm>
-            <a:off x="502920" y="2468880"/>
-            <a:ext cx="7040880" cy="1078992"/>
-          </a:xfrm>
-          <a:prstGeom prst="roundRect">
-            <a:avLst/>
-          </a:prstGeom>
-          <a:solidFill>
-            <a:srgbClr val="F8FAFC"/>
-          </a:solidFill>
-          <a:ln w="22225">
-            <a:solidFill>
-              <a:srgbClr val="E06D14"/>
-            </a:solidFill>
-          </a:ln>
-        </p:spPr>
-        <p:style>
-          <a:lnRef idx="1">
-            <a:schemeClr val="accent1"/>
-          </a:lnRef>
-          <a:fillRef idx="3">
-            <a:schemeClr val="accent1"/>
-          </a:fillRef>
-          <a:effectRef idx="2">
-            <a:schemeClr val="accent1"/>
-          </a:effectRef>
-          <a:fontRef idx="minor">
-            <a:schemeClr val="lt1"/>
-          </a:fontRef>
-        </p:style>
-        <p:txBody>
-          <a:bodyPr rtlCol="0" anchor="ctr"/>
-          <a:lstStyle/>
-          <a:p>
-            <a:pPr algn="ctr"/>
-          </a:p>
-        </p:txBody>
-      </p:sp>
-      <p:sp>
-        <p:nvSpPr>
-          <p:cNvPr id="17418" name="Rounded Rectangle 17417"/>
-          <p:cNvSpPr/>
-          <p:nvPr/>
-        </p:nvSpPr>
-        <p:spPr>
-          <a:xfrm>
-            <a:off x="594360" y="2523744"/>
-            <a:ext cx="3840480" cy="292608"/>
-          </a:xfrm>
-          <a:prstGeom prst="roundRect">
-            <a:avLst/>
-          </a:prstGeom>
-          <a:solidFill>
-            <a:srgbClr val="E06D14"/>
-          </a:solidFill>
-          <a:ln>
-            <a:noFill/>
-          </a:ln>
-        </p:spPr>
-        <p:style>
-          <a:lnRef idx="1">
-            <a:schemeClr val="accent1"/>
-          </a:lnRef>
-          <a:fillRef idx="3">
-            <a:schemeClr val="accent1"/>
-          </a:fillRef>
-          <a:effectRef idx="2">
-            <a:schemeClr val="accent1"/>
-          </a:effectRef>
-          <a:fontRef idx="minor">
-            <a:schemeClr val="lt1"/>
-          </a:fontRef>
-        </p:style>
-        <p:txBody>
-          <a:bodyPr rtlCol="0" anchor="ctr"/>
-          <a:lstStyle/>
-          <a:p>
-            <a:pPr algn="ctr">
-              <a:defRPr sz="1000" b="1">
-                <a:solidFill>
-                  <a:srgbClr val="FFFFFF"/>
-                </a:solidFill>
-                <a:latin typeface="Arial"/>
-              </a:defRPr>
-            </a:pPr>
-            <a:r>
-              <a:t>TIER 2: PREDICTIVE ANALYTICS &amp; BENCHMARK CORE</a:t>
-            </a:r>
-          </a:p>
-        </p:txBody>
-      </p:sp>
-      <p:sp>
-        <p:nvSpPr>
-          <p:cNvPr id="17419" name="Rounded Rectangle 17418"/>
-          <p:cNvSpPr/>
-          <p:nvPr/>
-        </p:nvSpPr>
-        <p:spPr>
-          <a:xfrm>
-            <a:off x="612648" y="2852928"/>
-            <a:ext cx="2194560" cy="621792"/>
+            <a:off x="4105656" y="3145536"/>
+            <a:ext cx="3236976" cy="658368"/>
           </a:xfrm>
           <a:prstGeom prst="roundRect">
             <a:avLst/>
@@ -8878,7 +8788,7 @@
           <a:lstStyle/>
           <a:p>
             <a:pPr algn="ctr">
-              <a:defRPr sz="950" b="1">
+              <a:defRPr sz="1150" b="1">
                 <a:solidFill>
                   <a:srgbClr val="E06D14"/>
                 </a:solidFill>
@@ -8886,15 +8796,12 @@
               </a:defRPr>
             </a:pPr>
             <a:r>
-              <a:t>📈 Cost Overrun Model</a:t>
-            </a:r>
-          </a:p>
-          <a:p>
-            <a:pPr>
-              <a:spcBef>
-                <a:spcPts val="200"/>
-              </a:spcBef>
-              <a:defRPr sz="850">
+              <a:t>📊 Scientific Benchmark (Dim b)</a:t>
+            </a:r>
+          </a:p>
+          <a:p>
+            <a:pPr>
+              <a:defRPr sz="1000">
                 <a:solidFill>
                   <a:srgbClr val="1E293B"/>
                 </a:solidFill>
@@ -8902,21 +8809,162 @@
               </a:defRPr>
             </a:pPr>
             <a:r>
-              <a:t>HistGradientBoosting Regressor (R² = 0.88, MAE = 3.2% Overrun)</a:t>
-            </a:r>
-          </a:p>
-        </p:txBody>
-      </p:sp>
-      <p:sp>
-        <p:nvSpPr>
-          <p:cNvPr id="17420" name="Rounded Rectangle 17419"/>
+              <a:t>+22.4% R² variance lift &amp; +0.12 AUC gain over classical linear models</a:t>
+            </a:r>
+          </a:p>
+        </p:txBody>
+      </p:sp>
+      <p:sp>
+        <p:nvSpPr>
+          <p:cNvPr id="17422" name="Down Arrow 17421"/>
           <p:cNvSpPr/>
           <p:nvPr/>
         </p:nvSpPr>
         <p:spPr>
           <a:xfrm>
-            <a:off x="2916936" y="2852928"/>
-            <a:ext cx="2194560" cy="621792"/>
+            <a:off x="3936491" y="3867911"/>
+            <a:ext cx="219456" cy="82296"/>
+          </a:xfrm>
+          <a:prstGeom prst="downArrow">
+            <a:avLst/>
+          </a:prstGeom>
+          <a:solidFill>
+            <a:srgbClr val="E06D14"/>
+          </a:solidFill>
+          <a:ln>
+            <a:noFill/>
+          </a:ln>
+        </p:spPr>
+        <p:style>
+          <a:lnRef idx="1">
+            <a:schemeClr val="accent1"/>
+          </a:lnRef>
+          <a:fillRef idx="3">
+            <a:schemeClr val="accent1"/>
+          </a:fillRef>
+          <a:effectRef idx="2">
+            <a:schemeClr val="accent1"/>
+          </a:effectRef>
+          <a:fontRef idx="minor">
+            <a:schemeClr val="lt1"/>
+          </a:fontRef>
+        </p:style>
+        <p:txBody>
+          <a:bodyPr rtlCol="0" anchor="ctr"/>
+          <a:lstStyle/>
+          <a:p>
+            <a:pPr algn="ctr"/>
+          </a:p>
+        </p:txBody>
+      </p:sp>
+      <p:sp>
+        <p:nvSpPr>
+          <p:cNvPr id="17423" name="Rounded Rectangle 17422"/>
+          <p:cNvSpPr/>
+          <p:nvPr/>
+        </p:nvSpPr>
+        <p:spPr>
+          <a:xfrm>
+            <a:off x="612648" y="3950208"/>
+            <a:ext cx="6867144" cy="1060704"/>
+          </a:xfrm>
+          <a:prstGeom prst="roundRect">
+            <a:avLst/>
+          </a:prstGeom>
+          <a:solidFill>
+            <a:srgbClr val="F8FAFC"/>
+          </a:solidFill>
+          <a:ln w="19050">
+            <a:solidFill>
+              <a:srgbClr val="0F1E36"/>
+            </a:solidFill>
+          </a:ln>
+        </p:spPr>
+        <p:style>
+          <a:lnRef idx="1">
+            <a:schemeClr val="accent1"/>
+          </a:lnRef>
+          <a:fillRef idx="3">
+            <a:schemeClr val="accent1"/>
+          </a:fillRef>
+          <a:effectRef idx="2">
+            <a:schemeClr val="accent1"/>
+          </a:effectRef>
+          <a:fontRef idx="minor">
+            <a:schemeClr val="lt1"/>
+          </a:fontRef>
+        </p:style>
+        <p:txBody>
+          <a:bodyPr rtlCol="0" anchor="ctr"/>
+          <a:lstStyle/>
+          <a:p>
+            <a:pPr algn="ctr"/>
+          </a:p>
+        </p:txBody>
+      </p:sp>
+      <p:sp>
+        <p:nvSpPr>
+          <p:cNvPr id="17424" name="Rounded Rectangle 17423"/>
+          <p:cNvSpPr/>
+          <p:nvPr/>
+        </p:nvSpPr>
+        <p:spPr>
+          <a:xfrm>
+            <a:off x="667512" y="3995928"/>
+            <a:ext cx="6757416" cy="274320"/>
+          </a:xfrm>
+          <a:prstGeom prst="roundRect">
+            <a:avLst/>
+          </a:prstGeom>
+          <a:solidFill>
+            <a:srgbClr val="0F1E36"/>
+          </a:solidFill>
+          <a:ln>
+            <a:noFill/>
+          </a:ln>
+        </p:spPr>
+        <p:style>
+          <a:lnRef idx="1">
+            <a:schemeClr val="accent1"/>
+          </a:lnRef>
+          <a:fillRef idx="3">
+            <a:schemeClr val="accent1"/>
+          </a:fillRef>
+          <a:effectRef idx="2">
+            <a:schemeClr val="accent1"/>
+          </a:effectRef>
+          <a:fontRef idx="minor">
+            <a:schemeClr val="lt1"/>
+          </a:fontRef>
+        </p:style>
+        <p:txBody>
+          <a:bodyPr rtlCol="0" anchor="ctr"/>
+          <a:lstStyle/>
+          <a:p>
+            <a:pPr algn="ctr">
+              <a:defRPr sz="1050" b="1">
+                <a:solidFill>
+                  <a:srgbClr val="FFFFFF"/>
+                </a:solidFill>
+                <a:latin typeface="Arial"/>
+              </a:defRPr>
+            </a:pPr>
+            <a:r>
+              <a:t>🛡️ LAYER 3: DECISION SUPPORT &amp; RISK SCORING</a:t>
+            </a:r>
+          </a:p>
+        </p:txBody>
+      </p:sp>
+      <p:sp>
+        <p:nvSpPr>
+          <p:cNvPr id="17425" name="Rounded Rectangle 17424"/>
+          <p:cNvSpPr/>
+          <p:nvPr/>
+        </p:nvSpPr>
+        <p:spPr>
+          <a:xfrm>
+            <a:off x="685800" y="4297680"/>
+            <a:ext cx="3236976" cy="658368"/>
           </a:xfrm>
           <a:prstGeom prst="roundRect">
             <a:avLst/>
@@ -8949,23 +8997,20 @@
           <a:lstStyle/>
           <a:p>
             <a:pPr algn="ctr">
-              <a:defRPr sz="950" b="1">
-                <a:solidFill>
-                  <a:srgbClr val="E06D14"/>
+              <a:defRPr sz="1150" b="1">
+                <a:solidFill>
+                  <a:srgbClr val="0F1E36"/>
                 </a:solidFill>
                 <a:latin typeface="Arial"/>
               </a:defRPr>
             </a:pPr>
             <a:r>
-              <a:t>⏱️ Time Delay Model</a:t>
-            </a:r>
-          </a:p>
-          <a:p>
-            <a:pPr>
-              <a:spcBef>
-                <a:spcPts val="200"/>
-              </a:spcBef>
-              <a:defRPr sz="850">
+              <a:t>🎯 Composite Risk Index (CRI)</a:t>
+            </a:r>
+          </a:p>
+          <a:p>
+            <a:pPr>
+              <a:defRPr sz="1000">
                 <a:solidFill>
                   <a:srgbClr val="1E293B"/>
                 </a:solidFill>
@@ -8973,21 +9018,21 @@
               </a:defRPr>
             </a:pPr>
             <a:r>
-              <a:t>Forecasts Schedule Slip in Months &amp; Revised Commissioning DOC</a:t>
-            </a:r>
-          </a:p>
-        </p:txBody>
-      </p:sp>
-      <p:sp>
-        <p:nvSpPr>
-          <p:cNvPr id="17421" name="Rounded Rectangle 17420"/>
+              <a:t>0–100 multi-dimensional risk score with dynamic Red/Amber/Green alerts</a:t>
+            </a:r>
+          </a:p>
+        </p:txBody>
+      </p:sp>
+      <p:sp>
+        <p:nvSpPr>
+          <p:cNvPr id="17426" name="Rounded Rectangle 17425"/>
           <p:cNvSpPr/>
           <p:nvPr/>
         </p:nvSpPr>
         <p:spPr>
           <a:xfrm>
-            <a:off x="5221224" y="2852928"/>
-            <a:ext cx="2194560" cy="621792"/>
+            <a:off x="4105656" y="4297680"/>
+            <a:ext cx="3236976" cy="658368"/>
           </a:xfrm>
           <a:prstGeom prst="roundRect">
             <a:avLst/>
@@ -9020,23 +9065,20 @@
           <a:lstStyle/>
           <a:p>
             <a:pPr algn="ctr">
-              <a:defRPr sz="950" b="1">
-                <a:solidFill>
-                  <a:srgbClr val="E06D14"/>
+              <a:defRPr sz="1150" b="1">
+                <a:solidFill>
+                  <a:srgbClr val="0F1E36"/>
                 </a:solidFill>
                 <a:latin typeface="Arial"/>
               </a:defRPr>
             </a:pPr>
             <a:r>
-              <a:t>🔬 Empirical Benchmark</a:t>
-            </a:r>
-          </a:p>
-          <a:p>
-            <a:pPr>
-              <a:spcBef>
-                <a:spcPts val="200"/>
-              </a:spcBef>
-              <a:defRPr sz="850">
+              <a:t>⚠️ 4 Early Warning Triggers</a:t>
+            </a:r>
+          </a:p>
+          <a:p>
+            <a:pPr>
+              <a:defRPr sz="1000">
                 <a:solidFill>
                   <a:srgbClr val="1E293B"/>
                 </a:solidFill>
@@ -9044,21 +9086,21 @@
               </a:defRPr>
             </a:pPr>
             <a:r>
-              <a:t>Empirical Proof: +22.4% R² Lift &amp; +0.12 AUC Gain over Linear OLS</a:t>
-            </a:r>
-          </a:p>
-        </p:txBody>
-      </p:sp>
-      <p:sp>
-        <p:nvSpPr>
-          <p:cNvPr id="17422" name="Down Arrow 17421"/>
+              <a:t>Ghost progress detection, clearance stalls &amp; What-If stress simulator</a:t>
+            </a:r>
+          </a:p>
+        </p:txBody>
+      </p:sp>
+      <p:sp>
+        <p:nvSpPr>
+          <p:cNvPr id="17427" name="Down Arrow 17426"/>
           <p:cNvSpPr/>
           <p:nvPr/>
         </p:nvSpPr>
         <p:spPr>
           <a:xfrm>
-            <a:off x="3913632" y="3566160"/>
-            <a:ext cx="219456" cy="164592"/>
+            <a:off x="3936491" y="5020056"/>
+            <a:ext cx="219456" cy="82296"/>
           </a:xfrm>
           <a:prstGeom prst="downArrow">
             <a:avLst/>
@@ -9094,14 +9136,14 @@
       </p:sp>
       <p:sp>
         <p:nvSpPr>
-          <p:cNvPr id="17423" name="Rounded Rectangle 17422"/>
+          <p:cNvPr id="17428" name="Rounded Rectangle 17427"/>
           <p:cNvSpPr/>
           <p:nvPr/>
         </p:nvSpPr>
         <p:spPr>
           <a:xfrm>
-            <a:off x="502920" y="3749039"/>
-            <a:ext cx="7040880" cy="1078992"/>
+            <a:off x="612648" y="5102352"/>
+            <a:ext cx="6867144" cy="1060704"/>
           </a:xfrm>
           <a:prstGeom prst="roundRect">
             <a:avLst/>
@@ -9109,9 +9151,9 @@
           <a:solidFill>
             <a:srgbClr val="F8FAFC"/>
           </a:solidFill>
-          <a:ln w="22225">
+          <a:ln w="19050">
             <a:solidFill>
-              <a:srgbClr val="0F1E36"/>
+              <a:srgbClr val="059669"/>
             </a:solidFill>
           </a:ln>
         </p:spPr>
@@ -9139,20 +9181,20 @@
       </p:sp>
       <p:sp>
         <p:nvSpPr>
-          <p:cNvPr id="17424" name="Rounded Rectangle 17423"/>
+          <p:cNvPr id="17429" name="Rounded Rectangle 17428"/>
           <p:cNvSpPr/>
           <p:nvPr/>
         </p:nvSpPr>
         <p:spPr>
           <a:xfrm>
-            <a:off x="594360" y="3803903"/>
-            <a:ext cx="3840480" cy="292608"/>
+            <a:off x="667512" y="5148072"/>
+            <a:ext cx="6757416" cy="274320"/>
           </a:xfrm>
           <a:prstGeom prst="roundRect">
             <a:avLst/>
           </a:prstGeom>
           <a:solidFill>
-            <a:srgbClr val="0F1E36"/>
+            <a:srgbClr val="059669"/>
           </a:solidFill>
           <a:ln>
             <a:noFill/>
@@ -9177,7 +9219,7 @@
           <a:lstStyle/>
           <a:p>
             <a:pPr algn="ctr">
-              <a:defRPr sz="1000" b="1">
+              <a:defRPr sz="1050" b="1">
                 <a:solidFill>
                   <a:srgbClr val="FFFFFF"/>
                 </a:solidFill>
@@ -9185,21 +9227,21 @@
               </a:defRPr>
             </a:pPr>
             <a:r>
-              <a:t>TIER 3: DECISION SUPPORT &amp; EARLY WARNING SYSTEM</a:t>
-            </a:r>
-          </a:p>
-        </p:txBody>
-      </p:sp>
-      <p:sp>
-        <p:nvSpPr>
-          <p:cNvPr id="17425" name="Rounded Rectangle 17424"/>
+              <a:t>💻 LAYER 4: ENTERPRISE DELIVERY &amp; AI COPILOT</a:t>
+            </a:r>
+          </a:p>
+        </p:txBody>
+      </p:sp>
+      <p:sp>
+        <p:nvSpPr>
+          <p:cNvPr id="17430" name="Rounded Rectangle 17429"/>
           <p:cNvSpPr/>
           <p:nvPr/>
         </p:nvSpPr>
         <p:spPr>
           <a:xfrm>
-            <a:off x="612648" y="4133087"/>
-            <a:ext cx="2194560" cy="621792"/>
+            <a:off x="685800" y="5449824"/>
+            <a:ext cx="3236976" cy="658368"/>
           </a:xfrm>
           <a:prstGeom prst="roundRect">
             <a:avLst/>
@@ -9232,23 +9274,20 @@
           <a:lstStyle/>
           <a:p>
             <a:pPr algn="ctr">
-              <a:defRPr sz="950" b="1">
-                <a:solidFill>
-                  <a:srgbClr val="0F1E36"/>
+              <a:defRPr sz="1150" b="1">
+                <a:solidFill>
+                  <a:srgbClr val="059669"/>
                 </a:solidFill>
                 <a:latin typeface="Arial"/>
               </a:defRPr>
             </a:pPr>
             <a:r>
-              <a:t>🎯 Composite Risk (CRI)</a:t>
-            </a:r>
-          </a:p>
-          <a:p>
-            <a:pPr>
-              <a:spcBef>
-                <a:spcPts val="200"/>
-              </a:spcBef>
-              <a:defRPr sz="850">
+              <a:t>⚡ FastAPI Microservice Engine</a:t>
+            </a:r>
+          </a:p>
+          <a:p>
+            <a:pPr>
+              <a:defRPr sz="1000">
                 <a:solidFill>
                   <a:srgbClr val="1E293B"/>
                 </a:solidFill>
@@ -9256,21 +9295,21 @@
               </a:defRPr>
             </a:pPr>
             <a:r>
-              <a:t>Multi-factor score (0-100) assigning dynamic RED / AMBER / GREEN status</a:t>
-            </a:r>
-          </a:p>
-        </p:txBody>
-      </p:sp>
-      <p:sp>
-        <p:nvSpPr>
-          <p:cNvPr id="17426" name="Rounded Rectangle 17425"/>
+              <a:t>High-concurrency async REST API with sub-5ms low latency inference</a:t>
+            </a:r>
+          </a:p>
+        </p:txBody>
+      </p:sp>
+      <p:sp>
+        <p:nvSpPr>
+          <p:cNvPr id="17431" name="Rounded Rectangle 17430"/>
           <p:cNvSpPr/>
           <p:nvPr/>
         </p:nvSpPr>
         <p:spPr>
           <a:xfrm>
-            <a:off x="2916936" y="4133087"/>
-            <a:ext cx="2194560" cy="621792"/>
+            <a:off x="4105656" y="5449824"/>
+            <a:ext cx="3236976" cy="658368"/>
           </a:xfrm>
           <a:prstGeom prst="roundRect">
             <a:avLst/>
@@ -9303,23 +9342,20 @@
           <a:lstStyle/>
           <a:p>
             <a:pPr algn="ctr">
-              <a:defRPr sz="950" b="1">
-                <a:solidFill>
-                  <a:srgbClr val="0F1E36"/>
+              <a:defRPr sz="1150" b="1">
+                <a:solidFill>
+                  <a:srgbClr val="059669"/>
                 </a:solidFill>
                 <a:latin typeface="Arial"/>
               </a:defRPr>
             </a:pPr>
             <a:r>
-              <a:t>🚨 4 Anomaly Triggers</a:t>
-            </a:r>
-          </a:p>
-          <a:p>
-            <a:pPr>
-              <a:spcBef>
-                <a:spcPts val="200"/>
-              </a:spcBef>
-              <a:defRPr sz="850">
+              <a:t>🧠 Interactive Dashboard &amp; Copilot</a:t>
+            </a:r>
+          </a:p>
+          <a:p>
+            <a:pPr>
+              <a:defRPr sz="1000">
                 <a:solidFill>
                   <a:srgbClr val="1E293B"/>
                 </a:solidFill>
@@ -9327,21 +9363,119 @@
               </a:defRPr>
             </a:pPr>
             <a:r>
-              <a:t>Autonomous Alerts: Ghost Progress, Clearance Cascade, Velocity Cliff</a:t>
-            </a:r>
-          </a:p>
-        </p:txBody>
-      </p:sp>
-      <p:sp>
-        <p:nvSpPr>
-          <p:cNvPr id="17427" name="Rounded Rectangle 17426"/>
+              <a:t>Executive dashboards, project drill-down &amp; 1-page ministerial briefs</a:t>
+            </a:r>
+          </a:p>
+        </p:txBody>
+      </p:sp>
+      <p:sp>
+        <p:nvSpPr>
+          <p:cNvPr id="17432" name="Rounded Rectangle 17431"/>
           <p:cNvSpPr/>
           <p:nvPr/>
         </p:nvSpPr>
         <p:spPr>
           <a:xfrm>
-            <a:off x="5221224" y="4133087"/>
-            <a:ext cx="2194560" cy="621792"/>
+            <a:off x="7772400" y="1115568"/>
+            <a:ext cx="3931920" cy="5166360"/>
+          </a:xfrm>
+          <a:prstGeom prst="roundRect">
+            <a:avLst/>
+          </a:prstGeom>
+          <a:solidFill>
+            <a:srgbClr val="F8FAFC"/>
+          </a:solidFill>
+          <a:ln w="19050">
+            <a:solidFill>
+              <a:srgbClr val="CBD5E1"/>
+            </a:solidFill>
+          </a:ln>
+        </p:spPr>
+        <p:style>
+          <a:lnRef idx="1">
+            <a:schemeClr val="accent1"/>
+          </a:lnRef>
+          <a:fillRef idx="3">
+            <a:schemeClr val="accent1"/>
+          </a:fillRef>
+          <a:effectRef idx="2">
+            <a:schemeClr val="accent1"/>
+          </a:effectRef>
+          <a:fontRef idx="minor">
+            <a:schemeClr val="lt1"/>
+          </a:fontRef>
+        </p:style>
+        <p:txBody>
+          <a:bodyPr rtlCol="0" anchor="ctr"/>
+          <a:lstStyle/>
+          <a:p>
+            <a:pPr algn="ctr"/>
+          </a:p>
+        </p:txBody>
+      </p:sp>
+      <p:sp>
+        <p:nvSpPr>
+          <p:cNvPr id="17433" name="Rounded Rectangle 17432"/>
+          <p:cNvSpPr/>
+          <p:nvPr/>
+        </p:nvSpPr>
+        <p:spPr>
+          <a:xfrm>
+            <a:off x="7882127" y="1188720"/>
+            <a:ext cx="3712463" cy="384048"/>
+          </a:xfrm>
+          <a:prstGeom prst="roundRect">
+            <a:avLst/>
+          </a:prstGeom>
+          <a:solidFill>
+            <a:srgbClr val="0F1E36"/>
+          </a:solidFill>
+          <a:ln>
+            <a:noFill/>
+          </a:ln>
+        </p:spPr>
+        <p:style>
+          <a:lnRef idx="1">
+            <a:schemeClr val="accent1"/>
+          </a:lnRef>
+          <a:fillRef idx="3">
+            <a:schemeClr val="accent1"/>
+          </a:fillRef>
+          <a:effectRef idx="2">
+            <a:schemeClr val="accent1"/>
+          </a:effectRef>
+          <a:fontRef idx="minor">
+            <a:schemeClr val="lt1"/>
+          </a:fontRef>
+        </p:style>
+        <p:txBody>
+          <a:bodyPr rtlCol="0" anchor="ctr"/>
+          <a:lstStyle/>
+          <a:p>
+            <a:pPr algn="ctr">
+              <a:defRPr sz="1300" b="1">
+                <a:solidFill>
+                  <a:srgbClr val="FFFFFF"/>
+                </a:solidFill>
+                <a:latin typeface="Arial"/>
+              </a:defRPr>
+            </a:pPr>
+            <a:r>
+              <a:t>TECHNOLOGY STACK &amp; OPEN TOOLS</a:t>
+            </a:r>
+          </a:p>
+        </p:txBody>
+      </p:sp>
+      <p:sp>
+        <p:nvSpPr>
+          <p:cNvPr id="17434" name="Rounded Rectangle 17433"/>
+          <p:cNvSpPr/>
+          <p:nvPr/>
+        </p:nvSpPr>
+        <p:spPr>
+          <a:xfrm>
+            <a:off x="7909560" y="1664208"/>
+            <a:ext cx="3657600" cy="694944"/>
           </a:xfrm>
           <a:prstGeom prst="roundRect">
             <a:avLst/>
@@ -9370,58 +9504,34 @@
           </a:fontRef>
         </p:style>
         <p:txBody>
-          <a:bodyPr rtlCol="0" anchor="ctr" wrap="square"/>
+          <a:bodyPr rtlCol="0" anchor="ctr"/>
           <a:lstStyle/>
           <a:p>
-            <a:pPr algn="ctr">
-              <a:defRPr sz="950" b="1">
-                <a:solidFill>
-                  <a:srgbClr val="0F1E36"/>
-                </a:solidFill>
-                <a:latin typeface="Arial"/>
-              </a:defRPr>
-            </a:pPr>
-            <a:r>
-              <a:t>🎛️ Scenario Simulator</a:t>
-            </a:r>
-          </a:p>
-          <a:p>
-            <a:pPr>
-              <a:spcBef>
-                <a:spcPts val="200"/>
-              </a:spcBef>
-              <a:defRPr sz="850">
-                <a:solidFill>
-                  <a:srgbClr val="1E293B"/>
-                </a:solidFill>
-                <a:latin typeface="Calibri"/>
-              </a:defRPr>
-            </a:pPr>
-            <a:r>
-              <a:t>Real-Time sensitivity sliders for clearance delays &amp; material inflation</a:t>
-            </a:r>
-          </a:p>
-        </p:txBody>
-      </p:sp>
-      <p:sp>
-        <p:nvSpPr>
-          <p:cNvPr id="17428" name="Down Arrow 17427"/>
+            <a:pPr algn="ctr"/>
+          </a:p>
+        </p:txBody>
+      </p:sp>
+      <p:sp>
+        <p:nvSpPr>
+          <p:cNvPr id="17435" name="Rounded Rectangle 17434"/>
           <p:cNvSpPr/>
           <p:nvPr/>
         </p:nvSpPr>
         <p:spPr>
           <a:xfrm>
-            <a:off x="3913632" y="4846319"/>
-            <a:ext cx="219456" cy="164592"/>
-          </a:xfrm>
-          <a:prstGeom prst="downArrow">
+            <a:off x="7982712" y="1764792"/>
+            <a:ext cx="960120" cy="493776"/>
+          </a:xfrm>
+          <a:prstGeom prst="roundRect">
             <a:avLst/>
           </a:prstGeom>
           <a:solidFill>
-            <a:srgbClr val="E06D14"/>
+            <a:srgbClr val="EFF6FF"/>
           </a:solidFill>
-          <a:ln>
-            <a:noFill/>
+          <a:ln w="12700">
+            <a:solidFill>
+              <a:srgbClr val="0F1E36"/>
+            </a:solidFill>
           </a:ln>
         </p:spPr>
         <p:style>
@@ -9442,118 +9552,79 @@
           <a:bodyPr rtlCol="0" anchor="ctr"/>
           <a:lstStyle/>
           <a:p>
-            <a:pPr algn="ctr"/>
-          </a:p>
-        </p:txBody>
-      </p:sp>
-      <p:sp>
-        <p:nvSpPr>
-          <p:cNvPr id="17429" name="Rounded Rectangle 17428"/>
+            <a:pPr algn="ctr">
+              <a:defRPr sz="1000" b="1">
+                <a:solidFill>
+                  <a:srgbClr val="0F1E36"/>
+                </a:solidFill>
+                <a:latin typeface="Arial"/>
+              </a:defRPr>
+            </a:pPr>
+            <a:r>
+              <a:t>🐍 Python</a:t>
+            </a:r>
+          </a:p>
+        </p:txBody>
+      </p:sp>
+      <p:sp>
+        <p:nvSpPr>
+          <p:cNvPr id="17436" name="TextBox 17435"/>
+          <p:cNvSpPr txBox="1"/>
+          <p:nvPr/>
+        </p:nvSpPr>
+        <p:spPr>
+          <a:xfrm>
+            <a:off x="8997696" y="1682496"/>
+            <a:ext cx="2514600" cy="658368"/>
+          </a:xfrm>
+          <a:prstGeom prst="rect">
+            <a:avLst/>
+          </a:prstGeom>
+          <a:noFill/>
+        </p:spPr>
+        <p:txBody>
+          <a:bodyPr wrap="square">
+            <a:spAutoFit/>
+          </a:bodyPr>
+          <a:lstStyle/>
+          <a:p>
+            <a:pPr>
+              <a:defRPr sz="1300" b="1">
+                <a:solidFill>
+                  <a:srgbClr val="0F1E36"/>
+                </a:solidFill>
+                <a:latin typeface="Arial"/>
+              </a:defRPr>
+            </a:pPr>
+            <a:r>
+              <a:t>Python 3.14</a:t>
+            </a:r>
+          </a:p>
+          <a:p>
+            <a:pPr>
+              <a:defRPr sz="1050">
+                <a:solidFill>
+                  <a:srgbClr val="1E293B"/>
+                </a:solidFill>
+                <a:latin typeface="Calibri"/>
+              </a:defRPr>
+            </a:pPr>
+            <a:r>
+              <a:t>Core data science, ML runtime &amp; pipeline engine</a:t>
+            </a:r>
+          </a:p>
+        </p:txBody>
+      </p:sp>
+      <p:sp>
+        <p:nvSpPr>
+          <p:cNvPr id="17437" name="Rounded Rectangle 17436"/>
           <p:cNvSpPr/>
           <p:nvPr/>
         </p:nvSpPr>
         <p:spPr>
           <a:xfrm>
-            <a:off x="502920" y="5029200"/>
-            <a:ext cx="7040880" cy="1143000"/>
-          </a:xfrm>
-          <a:prstGeom prst="roundRect">
-            <a:avLst/>
-          </a:prstGeom>
-          <a:solidFill>
-            <a:srgbClr val="F8FAFC"/>
-          </a:solidFill>
-          <a:ln w="22225">
-            <a:solidFill>
-              <a:srgbClr val="059669"/>
-            </a:solidFill>
-          </a:ln>
-        </p:spPr>
-        <p:style>
-          <a:lnRef idx="1">
-            <a:schemeClr val="accent1"/>
-          </a:lnRef>
-          <a:fillRef idx="3">
-            <a:schemeClr val="accent1"/>
-          </a:fillRef>
-          <a:effectRef idx="2">
-            <a:schemeClr val="accent1"/>
-          </a:effectRef>
-          <a:fontRef idx="minor">
-            <a:schemeClr val="lt1"/>
-          </a:fontRef>
-        </p:style>
-        <p:txBody>
-          <a:bodyPr rtlCol="0" anchor="ctr"/>
-          <a:lstStyle/>
-          <a:p>
-            <a:pPr algn="ctr"/>
-          </a:p>
-        </p:txBody>
-      </p:sp>
-      <p:sp>
-        <p:nvSpPr>
-          <p:cNvPr id="17430" name="Rounded Rectangle 17429"/>
-          <p:cNvSpPr/>
-          <p:nvPr/>
-        </p:nvSpPr>
-        <p:spPr>
-          <a:xfrm>
-            <a:off x="594360" y="5084064"/>
-            <a:ext cx="3840480" cy="292608"/>
-          </a:xfrm>
-          <a:prstGeom prst="roundRect">
-            <a:avLst/>
-          </a:prstGeom>
-          <a:solidFill>
-            <a:srgbClr val="059669"/>
-          </a:solidFill>
-          <a:ln>
-            <a:noFill/>
-          </a:ln>
-        </p:spPr>
-        <p:style>
-          <a:lnRef idx="1">
-            <a:schemeClr val="accent1"/>
-          </a:lnRef>
-          <a:fillRef idx="3">
-            <a:schemeClr val="accent1"/>
-          </a:fillRef>
-          <a:effectRef idx="2">
-            <a:schemeClr val="accent1"/>
-          </a:effectRef>
-          <a:fontRef idx="minor">
-            <a:schemeClr val="lt1"/>
-          </a:fontRef>
-        </p:style>
-        <p:txBody>
-          <a:bodyPr rtlCol="0" anchor="ctr"/>
-          <a:lstStyle/>
-          <a:p>
-            <a:pPr algn="ctr">
-              <a:defRPr sz="1000" b="1">
-                <a:solidFill>
-                  <a:srgbClr val="FFFFFF"/>
-                </a:solidFill>
-                <a:latin typeface="Arial"/>
-              </a:defRPr>
-            </a:pPr>
-            <a:r>
-              <a:t>TIER 4: ENTERPRISE DELIVERY &amp; AI ASSISTANT</a:t>
-            </a:r>
-          </a:p>
-        </p:txBody>
-      </p:sp>
-      <p:sp>
-        <p:nvSpPr>
-          <p:cNvPr id="17431" name="Rounded Rectangle 17430"/>
-          <p:cNvSpPr/>
-          <p:nvPr/>
-        </p:nvSpPr>
-        <p:spPr>
-          <a:xfrm>
-            <a:off x="612648" y="5413248"/>
-            <a:ext cx="2194560" cy="685800"/>
+            <a:off x="7909560" y="2450592"/>
+            <a:ext cx="3657600" cy="694944"/>
           </a:xfrm>
           <a:prstGeom prst="roundRect">
             <a:avLst/>
@@ -9582,49 +9653,127 @@
           </a:fontRef>
         </p:style>
         <p:txBody>
-          <a:bodyPr rtlCol="0" anchor="ctr" wrap="square"/>
+          <a:bodyPr rtlCol="0" anchor="ctr"/>
           <a:lstStyle/>
           <a:p>
-            <a:pPr algn="ctr">
-              <a:defRPr sz="950" b="1">
-                <a:solidFill>
-                  <a:srgbClr val="059669"/>
-                </a:solidFill>
-                <a:latin typeface="Arial"/>
-              </a:defRPr>
-            </a:pPr>
-            <a:r>
-              <a:t>⚡ FastAPI REST Engine</a:t>
-            </a:r>
-          </a:p>
-          <a:p>
-            <a:pPr>
-              <a:spcBef>
-                <a:spcPts val="200"/>
-              </a:spcBef>
-              <a:defRPr sz="850">
-                <a:solidFill>
-                  <a:srgbClr val="1E293B"/>
-                </a:solidFill>
-                <a:latin typeface="Calibri"/>
-              </a:defRPr>
-            </a:pPr>
-            <a:r>
-              <a:t>Asynchronous sub-5ms model inference &amp; auto-generated OpenAPI Swagger</a:t>
-            </a:r>
-          </a:p>
-        </p:txBody>
-      </p:sp>
-      <p:sp>
-        <p:nvSpPr>
-          <p:cNvPr id="17432" name="Rounded Rectangle 17431"/>
+            <a:pPr algn="ctr"/>
+          </a:p>
+        </p:txBody>
+      </p:sp>
+      <p:sp>
+        <p:nvSpPr>
+          <p:cNvPr id="17438" name="Rounded Rectangle 17437"/>
           <p:cNvSpPr/>
           <p:nvPr/>
         </p:nvSpPr>
         <p:spPr>
           <a:xfrm>
-            <a:off x="2916936" y="5413248"/>
-            <a:ext cx="2194560" cy="685800"/>
+            <a:off x="7982712" y="2551176"/>
+            <a:ext cx="960120" cy="493776"/>
+          </a:xfrm>
+          <a:prstGeom prst="roundRect">
+            <a:avLst/>
+          </a:prstGeom>
+          <a:solidFill>
+            <a:srgbClr val="FFF7ED"/>
+          </a:solidFill>
+          <a:ln w="12700">
+            <a:solidFill>
+              <a:srgbClr val="E06D14"/>
+            </a:solidFill>
+          </a:ln>
+        </p:spPr>
+        <p:style>
+          <a:lnRef idx="1">
+            <a:schemeClr val="accent1"/>
+          </a:lnRef>
+          <a:fillRef idx="3">
+            <a:schemeClr val="accent1"/>
+          </a:fillRef>
+          <a:effectRef idx="2">
+            <a:schemeClr val="accent1"/>
+          </a:effectRef>
+          <a:fontRef idx="minor">
+            <a:schemeClr val="lt1"/>
+          </a:fontRef>
+        </p:style>
+        <p:txBody>
+          <a:bodyPr rtlCol="0" anchor="ctr"/>
+          <a:lstStyle/>
+          <a:p>
+            <a:pPr algn="ctr">
+              <a:defRPr sz="1000" b="1">
+                <a:solidFill>
+                  <a:srgbClr val="E06D14"/>
+                </a:solidFill>
+                <a:latin typeface="Arial"/>
+              </a:defRPr>
+            </a:pPr>
+            <a:r>
+              <a:t>🤖 Scikit</a:t>
+            </a:r>
+          </a:p>
+        </p:txBody>
+      </p:sp>
+      <p:sp>
+        <p:nvSpPr>
+          <p:cNvPr id="17439" name="TextBox 17438"/>
+          <p:cNvSpPr txBox="1"/>
+          <p:nvPr/>
+        </p:nvSpPr>
+        <p:spPr>
+          <a:xfrm>
+            <a:off x="8997696" y="2468880"/>
+            <a:ext cx="2514600" cy="658368"/>
+          </a:xfrm>
+          <a:prstGeom prst="rect">
+            <a:avLst/>
+          </a:prstGeom>
+          <a:noFill/>
+        </p:spPr>
+        <p:txBody>
+          <a:bodyPr wrap="square">
+            <a:spAutoFit/>
+          </a:bodyPr>
+          <a:lstStyle/>
+          <a:p>
+            <a:pPr>
+              <a:defRPr sz="1300" b="1">
+                <a:solidFill>
+                  <a:srgbClr val="0F1E36"/>
+                </a:solidFill>
+                <a:latin typeface="Arial"/>
+              </a:defRPr>
+            </a:pPr>
+            <a:r>
+              <a:t>Scikit-Learn 1.9</a:t>
+            </a:r>
+          </a:p>
+          <a:p>
+            <a:pPr>
+              <a:defRPr sz="1050">
+                <a:solidFill>
+                  <a:srgbClr val="1E293B"/>
+                </a:solidFill>
+                <a:latin typeface="Calibri"/>
+              </a:defRPr>
+            </a:pPr>
+            <a:r>
+              <a:t>HistGradientBoosting, Random Forest &amp; GLM models</a:t>
+            </a:r>
+          </a:p>
+        </p:txBody>
+      </p:sp>
+      <p:sp>
+        <p:nvSpPr>
+          <p:cNvPr id="17440" name="Rounded Rectangle 17439"/>
+          <p:cNvSpPr/>
+          <p:nvPr/>
+        </p:nvSpPr>
+        <p:spPr>
+          <a:xfrm>
+            <a:off x="7909560" y="3236976"/>
+            <a:ext cx="3657600" cy="694944"/>
           </a:xfrm>
           <a:prstGeom prst="roundRect">
             <a:avLst/>
@@ -9653,49 +9802,127 @@
           </a:fontRef>
         </p:style>
         <p:txBody>
-          <a:bodyPr rtlCol="0" anchor="ctr" wrap="square"/>
+          <a:bodyPr rtlCol="0" anchor="ctr"/>
           <a:lstStyle/>
           <a:p>
-            <a:pPr algn="ctr">
-              <a:defRPr sz="950" b="1">
-                <a:solidFill>
-                  <a:srgbClr val="059669"/>
-                </a:solidFill>
-                <a:latin typeface="Arial"/>
-              </a:defRPr>
-            </a:pPr>
-            <a:r>
-              <a:t>📊 Executive Dashboard</a:t>
-            </a:r>
-          </a:p>
-          <a:p>
-            <a:pPr>
-              <a:spcBef>
-                <a:spcPts val="200"/>
-              </a:spcBef>
-              <a:defRPr sz="850">
-                <a:solidFill>
-                  <a:srgbClr val="1E293B"/>
-                </a:solidFill>
-                <a:latin typeface="Calibri"/>
-              </a:defRPr>
-            </a:pPr>
-            <a:r>
-              <a:t>Interactive portfolio analytics, project drilldown modals &amp; peer cohorts</a:t>
-            </a:r>
-          </a:p>
-        </p:txBody>
-      </p:sp>
-      <p:sp>
-        <p:nvSpPr>
-          <p:cNvPr id="17433" name="Rounded Rectangle 17432"/>
+            <a:pPr algn="ctr"/>
+          </a:p>
+        </p:txBody>
+      </p:sp>
+      <p:sp>
+        <p:nvSpPr>
+          <p:cNvPr id="17441" name="Rounded Rectangle 17440"/>
           <p:cNvSpPr/>
           <p:nvPr/>
         </p:nvSpPr>
         <p:spPr>
           <a:xfrm>
-            <a:off x="5221224" y="5413248"/>
-            <a:ext cx="2194560" cy="685800"/>
+            <a:off x="7982712" y="3337560"/>
+            <a:ext cx="960120" cy="493776"/>
+          </a:xfrm>
+          <a:prstGeom prst="roundRect">
+            <a:avLst/>
+          </a:prstGeom>
+          <a:solidFill>
+            <a:srgbClr val="F0FDF4"/>
+          </a:solidFill>
+          <a:ln w="12700">
+            <a:solidFill>
+              <a:srgbClr val="059669"/>
+            </a:solidFill>
+          </a:ln>
+        </p:spPr>
+        <p:style>
+          <a:lnRef idx="1">
+            <a:schemeClr val="accent1"/>
+          </a:lnRef>
+          <a:fillRef idx="3">
+            <a:schemeClr val="accent1"/>
+          </a:fillRef>
+          <a:effectRef idx="2">
+            <a:schemeClr val="accent1"/>
+          </a:effectRef>
+          <a:fontRef idx="minor">
+            <a:schemeClr val="lt1"/>
+          </a:fontRef>
+        </p:style>
+        <p:txBody>
+          <a:bodyPr rtlCol="0" anchor="ctr"/>
+          <a:lstStyle/>
+          <a:p>
+            <a:pPr algn="ctr">
+              <a:defRPr sz="1000" b="1">
+                <a:solidFill>
+                  <a:srgbClr val="059669"/>
+                </a:solidFill>
+                <a:latin typeface="Arial"/>
+              </a:defRPr>
+            </a:pPr>
+            <a:r>
+              <a:t>⚡ FastAPI</a:t>
+            </a:r>
+          </a:p>
+        </p:txBody>
+      </p:sp>
+      <p:sp>
+        <p:nvSpPr>
+          <p:cNvPr id="17442" name="TextBox 17441"/>
+          <p:cNvSpPr txBox="1"/>
+          <p:nvPr/>
+        </p:nvSpPr>
+        <p:spPr>
+          <a:xfrm>
+            <a:off x="8997696" y="3255264"/>
+            <a:ext cx="2514600" cy="658368"/>
+          </a:xfrm>
+          <a:prstGeom prst="rect">
+            <a:avLst/>
+          </a:prstGeom>
+          <a:noFill/>
+        </p:spPr>
+        <p:txBody>
+          <a:bodyPr wrap="square">
+            <a:spAutoFit/>
+          </a:bodyPr>
+          <a:lstStyle/>
+          <a:p>
+            <a:pPr>
+              <a:defRPr sz="1300" b="1">
+                <a:solidFill>
+                  <a:srgbClr val="0F1E36"/>
+                </a:solidFill>
+                <a:latin typeface="Arial"/>
+              </a:defRPr>
+            </a:pPr>
+            <a:r>
+              <a:t>FastAPI 0.141</a:t>
+            </a:r>
+          </a:p>
+          <a:p>
+            <a:pPr>
+              <a:defRPr sz="1050">
+                <a:solidFill>
+                  <a:srgbClr val="1E293B"/>
+                </a:solidFill>
+                <a:latin typeface="Calibri"/>
+              </a:defRPr>
+            </a:pPr>
+            <a:r>
+              <a:t>High-concurrency ASGI REST API (&lt;5ms latency)</a:t>
+            </a:r>
+          </a:p>
+        </p:txBody>
+      </p:sp>
+      <p:sp>
+        <p:nvSpPr>
+          <p:cNvPr id="17443" name="Rounded Rectangle 17442"/>
+          <p:cNvSpPr/>
+          <p:nvPr/>
+        </p:nvSpPr>
+        <p:spPr>
+          <a:xfrm>
+            <a:off x="7909560" y="4023360"/>
+            <a:ext cx="3657600" cy="694944"/>
           </a:xfrm>
           <a:prstGeom prst="roundRect">
             <a:avLst/>
@@ -9724,59 +9951,33 @@
           </a:fontRef>
         </p:style>
         <p:txBody>
-          <a:bodyPr rtlCol="0" anchor="ctr" wrap="square"/>
+          <a:bodyPr rtlCol="0" anchor="ctr"/>
           <a:lstStyle/>
           <a:p>
-            <a:pPr algn="ctr">
-              <a:defRPr sz="950" b="1">
-                <a:solidFill>
-                  <a:srgbClr val="059669"/>
-                </a:solidFill>
-                <a:latin typeface="Arial"/>
-              </a:defRPr>
-            </a:pPr>
-            <a:r>
-              <a:t>🧠 Project Copilot</a:t>
-            </a:r>
-          </a:p>
-          <a:p>
-            <a:pPr>
-              <a:spcBef>
-                <a:spcPts val="200"/>
-              </a:spcBef>
-              <a:defRPr sz="850">
-                <a:solidFill>
-                  <a:srgbClr val="1E293B"/>
-                </a:solidFill>
-                <a:latin typeface="Calibri"/>
-              </a:defRPr>
-            </a:pPr>
-            <a:r>
-              <a:t>Instant 1-page Ministerial briefs &amp; prescriptive bottleneck remedies</a:t>
-            </a:r>
-          </a:p>
-        </p:txBody>
-      </p:sp>
-      <p:sp>
-        <p:nvSpPr>
-          <p:cNvPr id="17434" name="Rounded Rectangle 17433"/>
+            <a:pPr algn="ctr"/>
+          </a:p>
+        </p:txBody>
+      </p:sp>
+      <p:sp>
+        <p:nvSpPr>
+          <p:cNvPr id="17444" name="Rounded Rectangle 17443"/>
           <p:cNvSpPr/>
           <p:nvPr/>
         </p:nvSpPr>
         <p:spPr>
           <a:xfrm>
-            <a:off x="7726679" y="1188720"/>
-            <a:ext cx="3977639" cy="4983480"/>
+            <a:off x="7982712" y="4123944"/>
+            <a:ext cx="960120" cy="493776"/>
           </a:xfrm>
           <a:prstGeom prst="roundRect">
             <a:avLst/>
           </a:prstGeom>
           <a:solidFill>
-            <a:srgbClr val="F8FAFC"/>
+            <a:srgbClr val="EFF6FF"/>
           </a:solidFill>
-          <a:ln>
+          <a:ln w="12700">
             <a:solidFill>
-              <a:srgbClr val="CBD5E1"/>
+              <a:srgbClr val="0F1E36"/>
             </a:solidFill>
           </a:ln>
         </p:spPr>
@@ -9798,29 +9999,90 @@
           <a:bodyPr rtlCol="0" anchor="ctr"/>
           <a:lstStyle/>
           <a:p>
-            <a:pPr algn="ctr"/>
-          </a:p>
-        </p:txBody>
-      </p:sp>
-      <p:sp>
-        <p:nvSpPr>
-          <p:cNvPr id="17435" name="Rounded Rectangle 17434"/>
+            <a:pPr algn="ctr">
+              <a:defRPr sz="1000" b="1">
+                <a:solidFill>
+                  <a:srgbClr val="0F1E36"/>
+                </a:solidFill>
+                <a:latin typeface="Arial"/>
+              </a:defRPr>
+            </a:pPr>
+            <a:r>
+              <a:t>🐼 Pandas</a:t>
+            </a:r>
+          </a:p>
+        </p:txBody>
+      </p:sp>
+      <p:sp>
+        <p:nvSpPr>
+          <p:cNvPr id="17445" name="TextBox 17444"/>
+          <p:cNvSpPr txBox="1"/>
+          <p:nvPr/>
+        </p:nvSpPr>
+        <p:spPr>
+          <a:xfrm>
+            <a:off x="8997696" y="4041648"/>
+            <a:ext cx="2514600" cy="658368"/>
+          </a:xfrm>
+          <a:prstGeom prst="rect">
+            <a:avLst/>
+          </a:prstGeom>
+          <a:noFill/>
+        </p:spPr>
+        <p:txBody>
+          <a:bodyPr wrap="square">
+            <a:spAutoFit/>
+          </a:bodyPr>
+          <a:lstStyle/>
+          <a:p>
+            <a:pPr>
+              <a:defRPr sz="1300" b="1">
+                <a:solidFill>
+                  <a:srgbClr val="0F1E36"/>
+                </a:solidFill>
+                <a:latin typeface="Arial"/>
+              </a:defRPr>
+            </a:pPr>
+            <a:r>
+              <a:t>Pandas &amp; NumPy</a:t>
+            </a:r>
+          </a:p>
+          <a:p>
+            <a:pPr>
+              <a:defRPr sz="1050">
+                <a:solidFill>
+                  <a:srgbClr val="1E293B"/>
+                </a:solidFill>
+                <a:latin typeface="Calibri"/>
+              </a:defRPr>
+            </a:pPr>
+            <a:r>
+              <a:t>High-speed data engineering &amp; CRI velocity ratios</a:t>
+            </a:r>
+          </a:p>
+        </p:txBody>
+      </p:sp>
+      <p:sp>
+        <p:nvSpPr>
+          <p:cNvPr id="17446" name="Rounded Rectangle 17445"/>
           <p:cNvSpPr/>
           <p:nvPr/>
         </p:nvSpPr>
         <p:spPr>
           <a:xfrm>
-            <a:off x="7863840" y="1298448"/>
-            <a:ext cx="3703320" cy="438912"/>
+            <a:off x="7909560" y="4809744"/>
+            <a:ext cx="3657600" cy="694944"/>
           </a:xfrm>
           <a:prstGeom prst="roundRect">
             <a:avLst/>
           </a:prstGeom>
           <a:solidFill>
-            <a:srgbClr val="0F1E36"/>
+            <a:srgbClr val="FFFFFF"/>
           </a:solidFill>
-          <a:ln>
-            <a:noFill/>
+          <a:ln w="12700">
+            <a:solidFill>
+              <a:srgbClr val="CBD5E1"/>
+            </a:solidFill>
           </a:ln>
         </p:spPr>
         <p:style>
@@ -9841,30 +10103,75 @@
           <a:bodyPr rtlCol="0" anchor="ctr"/>
           <a:lstStyle/>
           <a:p>
+            <a:pPr algn="ctr"/>
+          </a:p>
+        </p:txBody>
+      </p:sp>
+      <p:sp>
+        <p:nvSpPr>
+          <p:cNvPr id="17447" name="Rounded Rectangle 17446"/>
+          <p:cNvSpPr/>
+          <p:nvPr/>
+        </p:nvSpPr>
+        <p:spPr>
+          <a:xfrm>
+            <a:off x="7982712" y="4910328"/>
+            <a:ext cx="960120" cy="493776"/>
+          </a:xfrm>
+          <a:prstGeom prst="roundRect">
+            <a:avLst/>
+          </a:prstGeom>
+          <a:solidFill>
+            <a:srgbClr val="FFF7ED"/>
+          </a:solidFill>
+          <a:ln w="12700">
+            <a:solidFill>
+              <a:srgbClr val="E06D14"/>
+            </a:solidFill>
+          </a:ln>
+        </p:spPr>
+        <p:style>
+          <a:lnRef idx="1">
+            <a:schemeClr val="accent1"/>
+          </a:lnRef>
+          <a:fillRef idx="3">
+            <a:schemeClr val="accent1"/>
+          </a:fillRef>
+          <a:effectRef idx="2">
+            <a:schemeClr val="accent1"/>
+          </a:effectRef>
+          <a:fontRef idx="minor">
+            <a:schemeClr val="lt1"/>
+          </a:fontRef>
+        </p:style>
+        <p:txBody>
+          <a:bodyPr rtlCol="0" anchor="ctr"/>
+          <a:lstStyle/>
+          <a:p>
             <a:pPr algn="ctr">
-              <a:defRPr sz="1300" b="1">
-                <a:solidFill>
-                  <a:srgbClr val="FFFFFF"/>
+              <a:defRPr sz="1000" b="1">
+                <a:solidFill>
+                  <a:srgbClr val="E06D14"/>
                 </a:solidFill>
                 <a:latin typeface="Arial"/>
               </a:defRPr>
             </a:pPr>
             <a:r>
-              <a:t>TECHNOLOGY STACK &amp; OPEN TOOLS</a:t>
-            </a:r>
-          </a:p>
-        </p:txBody>
-      </p:sp>
-      <p:sp>
-        <p:nvSpPr>
-          <p:cNvPr id="17436" name="TextBox 17435"/>
+              <a:t>🎨 Tailwind</a:t>
+            </a:r>
+          </a:p>
+        </p:txBody>
+      </p:sp>
+      <p:sp>
+        <p:nvSpPr>
+          <p:cNvPr id="17448" name="TextBox 17447"/>
           <p:cNvSpPr txBox="1"/>
           <p:nvPr/>
         </p:nvSpPr>
         <p:spPr>
           <a:xfrm>
-            <a:off x="9372600" y="1828799"/>
-            <a:ext cx="2240279" cy="594360"/>
+            <a:off x="8997696" y="4828032"/>
+            <a:ext cx="2514600" cy="658368"/>
           </a:xfrm>
           <a:prstGeom prst="rect">
             <a:avLst/>
@@ -9878,7 +10185,7 @@
           <a:lstStyle/>
           <a:p>
             <a:pPr>
-              <a:defRPr sz="1200" b="1">
+              <a:defRPr sz="1300" b="1">
                 <a:solidFill>
                   <a:srgbClr val="0F1E36"/>
                 </a:solidFill>
@@ -9886,12 +10193,12 @@
               </a:defRPr>
             </a:pPr>
             <a:r>
-              <a:t>Python 3.14</a:t>
-            </a:r>
-          </a:p>
-          <a:p>
-            <a:pPr>
-              <a:defRPr sz="950">
+              <a:t>Tailwind &amp; Chart.js</a:t>
+            </a:r>
+          </a:p>
+          <a:p>
+            <a:pPr>
+              <a:defRPr sz="1050">
                 <a:solidFill>
                   <a:srgbClr val="1E293B"/>
                 </a:solidFill>
@@ -9899,217 +10206,21 @@
               </a:defRPr>
             </a:pPr>
             <a:r>
-              <a:t>Core data science &amp; ML runtime environment</a:t>
-            </a:r>
-          </a:p>
-        </p:txBody>
-      </p:sp>
-      <p:sp>
-        <p:nvSpPr>
-          <p:cNvPr id="17437" name="TextBox 17436"/>
-          <p:cNvSpPr txBox="1"/>
-          <p:nvPr/>
-        </p:nvSpPr>
-        <p:spPr>
-          <a:xfrm>
-            <a:off x="9372600" y="2578608"/>
-            <a:ext cx="2240279" cy="594360"/>
-          </a:xfrm>
-          <a:prstGeom prst="rect">
-            <a:avLst/>
-          </a:prstGeom>
-          <a:noFill/>
-        </p:spPr>
-        <p:txBody>
-          <a:bodyPr wrap="square">
-            <a:spAutoFit/>
-          </a:bodyPr>
-          <a:lstStyle/>
-          <a:p>
-            <a:pPr>
-              <a:defRPr sz="1200" b="1">
-                <a:solidFill>
-                  <a:srgbClr val="0F1E36"/>
-                </a:solidFill>
-                <a:latin typeface="Arial"/>
-              </a:defRPr>
-            </a:pPr>
-            <a:r>
-              <a:t>Scikit-Learn 1.9</a:t>
-            </a:r>
-          </a:p>
-          <a:p>
-            <a:pPr>
-              <a:defRPr sz="950">
-                <a:solidFill>
-                  <a:srgbClr val="1E293B"/>
-                </a:solidFill>
-                <a:latin typeface="Calibri"/>
-              </a:defRPr>
-            </a:pPr>
-            <a:r>
-              <a:t>HistGradientBoosting, Random Forest &amp; GLM pipelines</a:t>
-            </a:r>
-          </a:p>
-        </p:txBody>
-      </p:sp>
-      <p:sp>
-        <p:nvSpPr>
-          <p:cNvPr id="17438" name="TextBox 17437"/>
-          <p:cNvSpPr txBox="1"/>
-          <p:nvPr/>
-        </p:nvSpPr>
-        <p:spPr>
-          <a:xfrm>
-            <a:off x="9372600" y="3328415"/>
-            <a:ext cx="2240279" cy="594360"/>
-          </a:xfrm>
-          <a:prstGeom prst="rect">
-            <a:avLst/>
-          </a:prstGeom>
-          <a:noFill/>
-        </p:spPr>
-        <p:txBody>
-          <a:bodyPr wrap="square">
-            <a:spAutoFit/>
-          </a:bodyPr>
-          <a:lstStyle/>
-          <a:p>
-            <a:pPr>
-              <a:defRPr sz="1200" b="1">
-                <a:solidFill>
-                  <a:srgbClr val="0F1E36"/>
-                </a:solidFill>
-                <a:latin typeface="Arial"/>
-              </a:defRPr>
-            </a:pPr>
-            <a:r>
-              <a:t>FastAPI 0.141</a:t>
-            </a:r>
-          </a:p>
-          <a:p>
-            <a:pPr>
-              <a:defRPr sz="950">
-                <a:solidFill>
-                  <a:srgbClr val="1E293B"/>
-                </a:solidFill>
-                <a:latin typeface="Calibri"/>
-              </a:defRPr>
-            </a:pPr>
-            <a:r>
-              <a:t>High-concurrency ASGI REST engine (&lt;5ms latency)</a:t>
-            </a:r>
-          </a:p>
-        </p:txBody>
-      </p:sp>
-      <p:sp>
-        <p:nvSpPr>
-          <p:cNvPr id="17439" name="TextBox 17438"/>
-          <p:cNvSpPr txBox="1"/>
-          <p:nvPr/>
-        </p:nvSpPr>
-        <p:spPr>
-          <a:xfrm>
-            <a:off x="9372600" y="4078224"/>
-            <a:ext cx="2240279" cy="594360"/>
-          </a:xfrm>
-          <a:prstGeom prst="rect">
-            <a:avLst/>
-          </a:prstGeom>
-          <a:noFill/>
-        </p:spPr>
-        <p:txBody>
-          <a:bodyPr wrap="square">
-            <a:spAutoFit/>
-          </a:bodyPr>
-          <a:lstStyle/>
-          <a:p>
-            <a:pPr>
-              <a:defRPr sz="1200" b="1">
-                <a:solidFill>
-                  <a:srgbClr val="0F1E36"/>
-                </a:solidFill>
-                <a:latin typeface="Arial"/>
-              </a:defRPr>
-            </a:pPr>
-            <a:r>
-              <a:t>Pandas &amp; NumPy</a:t>
-            </a:r>
-          </a:p>
-          <a:p>
-            <a:pPr>
-              <a:defRPr sz="950">
-                <a:solidFill>
-                  <a:srgbClr val="1E293B"/>
-                </a:solidFill>
-                <a:latin typeface="Calibri"/>
-              </a:defRPr>
-            </a:pPr>
-            <a:r>
-              <a:t>High-throughput feature engineering &amp; ratio derivations</a:t>
-            </a:r>
-          </a:p>
-        </p:txBody>
-      </p:sp>
-      <p:sp>
-        <p:nvSpPr>
-          <p:cNvPr id="17440" name="TextBox 17439"/>
-          <p:cNvSpPr txBox="1"/>
-          <p:nvPr/>
-        </p:nvSpPr>
-        <p:spPr>
-          <a:xfrm>
-            <a:off x="9372600" y="4828032"/>
-            <a:ext cx="2240279" cy="594360"/>
-          </a:xfrm>
-          <a:prstGeom prst="rect">
-            <a:avLst/>
-          </a:prstGeom>
-          <a:noFill/>
-        </p:spPr>
-        <p:txBody>
-          <a:bodyPr wrap="square">
-            <a:spAutoFit/>
-          </a:bodyPr>
-          <a:lstStyle/>
-          <a:p>
-            <a:pPr>
-              <a:defRPr sz="1200" b="1">
-                <a:solidFill>
-                  <a:srgbClr val="0F1E36"/>
-                </a:solidFill>
-                <a:latin typeface="Arial"/>
-              </a:defRPr>
-            </a:pPr>
-            <a:r>
-              <a:t>Tailwind &amp; Chart.js</a:t>
-            </a:r>
-          </a:p>
-          <a:p>
-            <a:pPr>
-              <a:defRPr sz="950">
-                <a:solidFill>
-                  <a:srgbClr val="1E293B"/>
-                </a:solidFill>
-                <a:latin typeface="Calibri"/>
-              </a:defRPr>
-            </a:pPr>
-            <a:r>
-              <a:t>Modern responsive web UI &amp; interactive data analytics</a:t>
-            </a:r>
-          </a:p>
-        </p:txBody>
-      </p:sp>
-      <p:sp>
-        <p:nvSpPr>
-          <p:cNvPr id="17441" name="Rounded Rectangle 17440"/>
+              <a:t>Modern responsive web portal &amp; interactive visual charts</a:t>
+            </a:r>
+          </a:p>
+        </p:txBody>
+      </p:sp>
+      <p:sp>
+        <p:nvSpPr>
+          <p:cNvPr id="17449" name="Rounded Rectangle 17448"/>
           <p:cNvSpPr/>
           <p:nvPr/>
         </p:nvSpPr>
         <p:spPr>
           <a:xfrm>
-            <a:off x="7863840" y="5596128"/>
-            <a:ext cx="3703320" cy="475488"/>
+            <a:off x="7909560" y="5669280"/>
+            <a:ext cx="3657600" cy="502920"/>
           </a:xfrm>
           <a:prstGeom prst="roundRect">
             <a:avLst/>
@@ -10140,7 +10251,7 @@
           <a:lstStyle/>
           <a:p>
             <a:pPr algn="ctr">
-              <a:defRPr sz="1050" b="1">
+              <a:defRPr sz="1150" b="1">
                 <a:solidFill>
                   <a:srgbClr val="FFFFFF"/>
                 </a:solidFill>
@@ -10148,7 +10259,7 @@
               </a:defRPr>
             </a:pPr>
             <a:r>
-              <a:t>✓ 100% Open Source | Zero Licensing Fees | 2 vCPUs</a:t>
+              <a:t>✓ 100% Open Source | 2 vCPUs | Zero GPU Cost</a:t>
             </a:r>
           </a:p>
         </p:txBody>
@@ -12813,859 +12924,6 @@
     <p:extLst>
       <p:ext uri="{BB962C8B-B14F-4D97-AF65-F5344CB8AC3E}">
         <p14:creationId xmlns:p14="http://schemas.microsoft.com/office/powerpoint/2010/main" val="3916788613"/>
-      </p:ext>
-    </p:extLst>
-  </p:cSld>
-  <p:clrMapOvr>
-    <a:masterClrMapping/>
-  </p:clrMapOvr>
-</p:sld>
-</file>
-
-<file path=ppt/slides/slide7.xml><?xml version="1.0" encoding="utf-8"?>
-<p:sld xmlns:a="http://schemas.openxmlformats.org/drawingml/2006/main" xmlns:r="http://schemas.openxmlformats.org/officeDocument/2006/relationships" xmlns:p="http://schemas.openxmlformats.org/presentationml/2006/main">
-  <p:cSld>
-    <p:spTree>
-      <p:nvGrpSpPr>
-        <p:cNvPr id="1" name=""/>
-        <p:cNvGrpSpPr/>
-        <p:nvPr/>
-      </p:nvGrpSpPr>
-      <p:grpSpPr>
-        <a:xfrm>
-          <a:off x="0" y="0"/>
-          <a:ext cx="0" cy="0"/>
-          <a:chOff x="0" y="0"/>
-          <a:chExt cx="0" cy="0"/>
-        </a:xfrm>
-      </p:grpSpPr>
-      <p:sp>
-        <p:nvSpPr>
-          <p:cNvPr id="10" name="Rectangle 9">
-            <a:extLst>
-              <a:ext uri="{FF2B5EF4-FFF2-40B4-BE49-F238E27FC236}">
-                <a16:creationId xmlns:a16="http://schemas.microsoft.com/office/drawing/2014/main" id="{AD4F69D3-EEB0-4C4C-9434-B9960FB5854C}"/>
-              </a:ext>
-            </a:extLst>
-          </p:cNvPr>
-          <p:cNvSpPr>
-            <a:spLocks noChangeArrowheads="1"/>
-          </p:cNvSpPr>
-          <p:nvPr/>
-        </p:nvSpPr>
-        <p:spPr bwMode="auto">
-          <a:xfrm>
-            <a:off x="0" y="6354762"/>
-            <a:ext cx="12191999" cy="503238"/>
-          </a:xfrm>
-          <a:prstGeom prst="rect">
-            <a:avLst/>
-          </a:prstGeom>
-          <a:solidFill>
-            <a:srgbClr val="0070C0"/>
-          </a:solidFill>
-          <a:ln w="9525">
-            <a:noFill/>
-            <a:miter lim="800000"/>
-            <a:headEnd/>
-            <a:tailEnd/>
-          </a:ln>
-          <a:effectLst>
-            <a:outerShdw dist="23000" dir="5400000" rotWithShape="0">
-              <a:srgbClr val="808080">
-                <a:alpha val="34999"/>
-              </a:srgbClr>
-            </a:outerShdw>
-          </a:effectLst>
-        </p:spPr>
-        <p:txBody>
-          <a:bodyPr anchor="ctr"/>
-          <a:lstStyle/>
-          <a:p>
-            <a:pPr marL="0" marR="0" lvl="0" indent="0" algn="ctr" defTabSz="457200" rtl="0" eaLnBrk="1" fontAlgn="auto" latinLnBrk="0" hangingPunct="1">
-              <a:lnSpc>
-                <a:spcPct val="100000"/>
-              </a:lnSpc>
-              <a:spcBef>
-                <a:spcPts val="0"/>
-              </a:spcBef>
-              <a:spcAft>
-                <a:spcPts val="0"/>
-              </a:spcAft>
-              <a:buClrTx/>
-              <a:buSzTx/>
-              <a:buFontTx/>
-              <a:buNone/>
-              <a:tabLst/>
-              <a:defRPr/>
-            </a:pPr>
-            <a:endParaRPr kumimoji="0" lang="en-US" sz="1800" b="0" i="0" u="none" strike="noStrike" kern="1200" cap="none" spc="0" normalizeH="0" baseline="0" noProof="0" dirty="0">
-              <a:ln>
-                <a:noFill/>
-              </a:ln>
-              <a:solidFill>
-                <a:srgbClr val="C0504D">
-                  <a:lumMod val="75000"/>
-                </a:srgbClr>
-              </a:solidFill>
-              <a:effectLst/>
-              <a:uLnTx/>
-              <a:uFillTx/>
-              <a:latin typeface="Calibri"/>
-              <a:ea typeface="ＭＳ Ｐゴシック" pitchFamily="1" charset="-128"/>
-              <a:cs typeface="+mn-cs"/>
-            </a:endParaRPr>
-          </a:p>
-        </p:txBody>
-      </p:sp>
-      <p:sp>
-        <p:nvSpPr>
-          <p:cNvPr id="6" name="Slide Number Placeholder 5"/>
-          <p:cNvSpPr>
-            <a:spLocks noGrp="1"/>
-          </p:cNvSpPr>
-          <p:nvPr>
-            <p:ph type="sldNum" sz="quarter" idx="12"/>
-          </p:nvPr>
-        </p:nvSpPr>
-        <p:spPr/>
-        <p:txBody>
-          <a:bodyPr/>
-          <a:lstStyle/>
-          <a:p>
-            <a:pPr marL="0" marR="0" lvl="0" indent="0" algn="r" defTabSz="457200" rtl="0" eaLnBrk="1" fontAlgn="base" latinLnBrk="0" hangingPunct="1">
-              <a:lnSpc>
-                <a:spcPct val="100000"/>
-              </a:lnSpc>
-              <a:spcBef>
-                <a:spcPct val="0"/>
-              </a:spcBef>
-              <a:spcAft>
-                <a:spcPct val="0"/>
-              </a:spcAft>
-              <a:buClrTx/>
-              <a:buSzTx/>
-              <a:buFontTx/>
-              <a:buNone/>
-              <a:tabLst/>
-              <a:defRPr/>
-            </a:pPr>
-            <a:fld id="{677C3CE7-23F7-4828-823C-E0205DF2CF97}" type="slidenum">
-              <a:rPr kumimoji="0" lang="en-US" sz="1200" b="1" i="0" u="none" strike="noStrike" kern="1200" cap="none" spc="0" normalizeH="0" baseline="0" noProof="0">
-                <a:ln>
-                  <a:noFill/>
-                </a:ln>
-                <a:solidFill>
-                  <a:prstClr val="white"/>
-                </a:solidFill>
-                <a:effectLst/>
-                <a:uLnTx/>
-                <a:uFillTx/>
-                <a:latin typeface="TradeGothic" pitchFamily="1" charset="0"/>
-                <a:ea typeface="ＭＳ Ｐゴシック" pitchFamily="1" charset="-128"/>
-                <a:cs typeface="+mn-cs"/>
-              </a:rPr>
-              <a:pPr marL="0" marR="0" lvl="0" indent="0" algn="r" defTabSz="457200" rtl="0" eaLnBrk="1" fontAlgn="base" latinLnBrk="0" hangingPunct="1">
-                <a:lnSpc>
-                  <a:spcPct val="100000"/>
-                </a:lnSpc>
-                <a:spcBef>
-                  <a:spcPct val="0"/>
-                </a:spcBef>
-                <a:spcAft>
-                  <a:spcPct val="0"/>
-                </a:spcAft>
-                <a:buClrTx/>
-                <a:buSzTx/>
-                <a:buFontTx/>
-                <a:buNone/>
-                <a:tabLst/>
-                <a:defRPr/>
-              </a:pPr>
-              <a:t>7</a:t>
-            </a:fld>
-            <a:endParaRPr kumimoji="0" lang="en-US" sz="1200" b="1" i="0" u="none" strike="noStrike" kern="1200" cap="none" spc="0" normalizeH="0" baseline="0" noProof="0" dirty="0">
-              <a:ln>
-                <a:noFill/>
-              </a:ln>
-              <a:solidFill>
-                <a:prstClr val="white"/>
-              </a:solidFill>
-              <a:effectLst/>
-              <a:uLnTx/>
-              <a:uFillTx/>
-              <a:latin typeface="TradeGothic" pitchFamily="1" charset="0"/>
-              <a:ea typeface="ＭＳ Ｐゴシック" pitchFamily="1" charset="-128"/>
-              <a:cs typeface="+mn-cs"/>
-            </a:endParaRPr>
-          </a:p>
-        </p:txBody>
-      </p:sp>
-      <p:sp>
-        <p:nvSpPr>
-          <p:cNvPr id="7" name="Footer Placeholder 6"/>
-          <p:cNvSpPr>
-            <a:spLocks noGrp="1"/>
-          </p:cNvSpPr>
-          <p:nvPr>
-            <p:ph type="ftr" sz="quarter" idx="11"/>
-          </p:nvPr>
-        </p:nvSpPr>
-        <p:spPr>
-          <a:xfrm>
-            <a:off x="4648200" y="6356353"/>
-            <a:ext cx="3204000" cy="365125"/>
-          </a:xfrm>
-        </p:spPr>
-        <p:txBody>
-          <a:bodyPr/>
-          <a:lstStyle/>
-          <a:p>
-            <a:pPr marL="0" marR="0" lvl="0" indent="0" algn="ctr" defTabSz="457200" rtl="0" eaLnBrk="1" fontAlgn="auto" latinLnBrk="0" hangingPunct="1">
-              <a:lnSpc>
-                <a:spcPct val="100000"/>
-              </a:lnSpc>
-              <a:spcBef>
-                <a:spcPts val="0"/>
-              </a:spcBef>
-              <a:spcAft>
-                <a:spcPts val="0"/>
-              </a:spcAft>
-              <a:buClrTx/>
-              <a:buSzTx/>
-              <a:buFontTx/>
-              <a:buNone/>
-              <a:tabLst/>
-              <a:defRPr/>
-            </a:pPr>
-            <a:r>
-              <a:rPr kumimoji="0" lang="en-US" sz="1200" b="0" i="0" u="none" strike="noStrike" kern="1200" cap="none" spc="0" normalizeH="0" baseline="0" noProof="0">
-                <a:ln>
-                  <a:noFill/>
-                </a:ln>
-                <a:solidFill>
-                  <a:prstClr val="white"/>
-                </a:solidFill>
-                <a:effectLst/>
-                <a:uLnTx/>
-                <a:uFillTx/>
-                <a:latin typeface="TradeGothic"/>
-                <a:ea typeface="+mn-ea"/>
-                <a:cs typeface="+mn-cs"/>
-              </a:rPr>
-              <a:t>@SIH Idea submission- Template</a:t>
-            </a:r>
-            <a:endParaRPr kumimoji="0" lang="en-US" sz="1200" b="0" i="0" u="none" strike="noStrike" kern="1200" cap="none" spc="0" normalizeH="0" baseline="0" noProof="0" dirty="0">
-              <a:ln>
-                <a:noFill/>
-              </a:ln>
-              <a:solidFill>
-                <a:prstClr val="white"/>
-              </a:solidFill>
-              <a:effectLst/>
-              <a:uLnTx/>
-              <a:uFillTx/>
-              <a:latin typeface="TradeGothic"/>
-              <a:ea typeface="+mn-ea"/>
-              <a:cs typeface="+mn-cs"/>
-            </a:endParaRPr>
-          </a:p>
-        </p:txBody>
-      </p:sp>
-      <p:sp>
-        <p:nvSpPr>
-          <p:cNvPr id="3" name="Round Diagonal Corner Rectangle 2"/>
-          <p:cNvSpPr/>
-          <p:nvPr/>
-        </p:nvSpPr>
-        <p:spPr>
-          <a:xfrm>
-            <a:off x="0" y="1791032"/>
-            <a:ext cx="12192000" cy="4319200"/>
-          </a:xfrm>
-          <a:prstGeom prst="round2DiagRect">
-            <a:avLst/>
-          </a:prstGeom>
-          <a:solidFill>
-            <a:schemeClr val="accent1">
-              <a:lumMod val="20000"/>
-              <a:lumOff val="80000"/>
-            </a:schemeClr>
-          </a:solidFill>
-          <a:ln w="38100"/>
-        </p:spPr>
-        <p:style>
-          <a:lnRef idx="1">
-            <a:schemeClr val="accent1"/>
-          </a:lnRef>
-          <a:fillRef idx="3">
-            <a:schemeClr val="accent1"/>
-          </a:fillRef>
-          <a:effectRef idx="2">
-            <a:schemeClr val="accent1"/>
-          </a:effectRef>
-          <a:fontRef idx="minor">
-            <a:schemeClr val="lt1"/>
-          </a:fontRef>
-        </p:style>
-        <p:txBody>
-          <a:bodyPr rtlCol="0" anchor="ctr"/>
-          <a:lstStyle/>
-          <a:p>
-            <a:pPr algn="ctr"/>
-            <a:endParaRPr lang="en-IN"/>
-          </a:p>
-        </p:txBody>
-      </p:sp>
-      <p:sp>
-        <p:nvSpPr>
-          <p:cNvPr id="12" name="Google Shape;100;p3"/>
-          <p:cNvSpPr txBox="1"/>
-          <p:nvPr/>
-        </p:nvSpPr>
-        <p:spPr>
-          <a:xfrm>
-            <a:off x="367832" y="1915454"/>
-            <a:ext cx="11764736" cy="4070356"/>
-          </a:xfrm>
-          <a:prstGeom prst="rect">
-            <a:avLst/>
-          </a:prstGeom>
-          <a:noFill/>
-          <a:ln>
-            <a:noFill/>
-          </a:ln>
-        </p:spPr>
-        <p:txBody>
-          <a:bodyPr spcFirstLastPara="1" wrap="square" lIns="91425" tIns="45700" rIns="91425" bIns="45700" anchor="t" anchorCtr="0">
-            <a:noAutofit/>
-          </a:bodyPr>
-          <a:lstStyle/>
-          <a:p>
-            <a:pPr marL="514350" marR="0" lvl="0" indent="-514350" algn="just" rtl="0">
-              <a:lnSpc>
-                <a:spcPct val="90000"/>
-              </a:lnSpc>
-              <a:spcBef>
-                <a:spcPts val="0"/>
-              </a:spcBef>
-              <a:spcAft>
-                <a:spcPts val="0"/>
-              </a:spcAft>
-              <a:buClr>
-                <a:schemeClr val="dk1"/>
-              </a:buClr>
-              <a:buSzPct val="100000"/>
-              <a:buFont typeface="Calibri"/>
-              <a:buAutoNum type="arabicPeriod"/>
-            </a:pPr>
-            <a:r>
-              <a:rPr lang="en-US" b="1" i="0" u="none" strike="noStrike" cap="none" dirty="0">
-                <a:solidFill>
-                  <a:schemeClr val="dk1"/>
-                </a:solidFill>
-                <a:latin typeface="Arial" panose="020B0604020202020204" pitchFamily="34" charset="0"/>
-                <a:ea typeface="Calibri"/>
-                <a:cs typeface="Arial" panose="020B0604020202020204" pitchFamily="34" charset="0"/>
-                <a:sym typeface="Calibri"/>
-              </a:rPr>
-              <a:t>Kindly keep the maximum slides limit up to six </a:t>
-            </a:r>
-            <a:r>
-              <a:rPr lang="en-US" b="1" i="0" u="none" strike="noStrike" cap="none" dirty="0">
-                <a:solidFill>
-                  <a:srgbClr val="C00000"/>
-                </a:solidFill>
-                <a:latin typeface="Arial" panose="020B0604020202020204" pitchFamily="34" charset="0"/>
-                <a:ea typeface="Calibri"/>
-                <a:cs typeface="Arial" panose="020B0604020202020204" pitchFamily="34" charset="0"/>
-                <a:sym typeface="Calibri"/>
-              </a:rPr>
-              <a:t>(6). </a:t>
-            </a:r>
-            <a:r>
-              <a:rPr lang="en-US" b="1" i="0" u="none" strike="noStrike" cap="none" dirty="0">
-                <a:solidFill>
-                  <a:schemeClr val="dk1"/>
-                </a:solidFill>
-                <a:latin typeface="Arial" panose="020B0604020202020204" pitchFamily="34" charset="0"/>
-                <a:ea typeface="Calibri"/>
-                <a:cs typeface="Arial" panose="020B0604020202020204" pitchFamily="34" charset="0"/>
-                <a:sym typeface="Calibri"/>
-              </a:rPr>
-              <a:t>( Including the </a:t>
-            </a:r>
-            <a:r>
-              <a:rPr lang="en-US" b="1" i="0" u="none" strike="noStrike" cap="none">
-                <a:solidFill>
-                  <a:schemeClr val="dk1"/>
-                </a:solidFill>
-                <a:latin typeface="Arial" panose="020B0604020202020204" pitchFamily="34" charset="0"/>
-                <a:ea typeface="Calibri"/>
-                <a:cs typeface="Arial" panose="020B0604020202020204" pitchFamily="34" charset="0"/>
-                <a:sym typeface="Calibri"/>
-              </a:rPr>
-              <a:t>title slide) </a:t>
-            </a:r>
-            <a:endParaRPr b="1" dirty="0">
-              <a:latin typeface="Arial" panose="020B0604020202020204" pitchFamily="34" charset="0"/>
-              <a:cs typeface="Arial" panose="020B0604020202020204" pitchFamily="34" charset="0"/>
-            </a:endParaRPr>
-          </a:p>
-          <a:p>
-            <a:pPr marL="514350" marR="0" lvl="0" indent="-514350" algn="just" rtl="0">
-              <a:lnSpc>
-                <a:spcPct val="90000"/>
-              </a:lnSpc>
-              <a:spcBef>
-                <a:spcPts val="1000"/>
-              </a:spcBef>
-              <a:spcAft>
-                <a:spcPts val="0"/>
-              </a:spcAft>
-              <a:buClr>
-                <a:schemeClr val="dk1"/>
-              </a:buClr>
-              <a:buSzPct val="100000"/>
-              <a:buFont typeface="Calibri"/>
-              <a:buAutoNum type="arabicPeriod"/>
-            </a:pPr>
-            <a:r>
-              <a:rPr lang="en-US" b="1" i="0" u="none" strike="noStrike" cap="none" dirty="0">
-                <a:solidFill>
-                  <a:schemeClr val="dk1"/>
-                </a:solidFill>
-                <a:latin typeface="Arial" panose="020B0604020202020204" pitchFamily="34" charset="0"/>
-                <a:ea typeface="Calibri"/>
-                <a:cs typeface="Arial" panose="020B0604020202020204" pitchFamily="34" charset="0"/>
-                <a:sym typeface="Calibri"/>
-              </a:rPr>
-              <a:t>Try to avoid paragraphs and post your idea in points /diagrams / Infographics /pictures </a:t>
-            </a:r>
-            <a:endParaRPr b="1" dirty="0">
-              <a:latin typeface="Arial" panose="020B0604020202020204" pitchFamily="34" charset="0"/>
-              <a:cs typeface="Arial" panose="020B0604020202020204" pitchFamily="34" charset="0"/>
-            </a:endParaRPr>
-          </a:p>
-          <a:p>
-            <a:pPr marL="514350" marR="0" lvl="0" indent="-514350" algn="just" rtl="0">
-              <a:lnSpc>
-                <a:spcPct val="90000"/>
-              </a:lnSpc>
-              <a:spcBef>
-                <a:spcPts val="1000"/>
-              </a:spcBef>
-              <a:spcAft>
-                <a:spcPts val="0"/>
-              </a:spcAft>
-              <a:buClr>
-                <a:schemeClr val="dk1"/>
-              </a:buClr>
-              <a:buSzPct val="100000"/>
-              <a:buFont typeface="Calibri"/>
-              <a:buAutoNum type="arabicPeriod"/>
-            </a:pPr>
-            <a:r>
-              <a:rPr lang="en-US" b="1" i="0" u="none" strike="noStrike" cap="none" dirty="0">
-                <a:solidFill>
-                  <a:schemeClr val="dk1"/>
-                </a:solidFill>
-                <a:latin typeface="Arial" panose="020B0604020202020204" pitchFamily="34" charset="0"/>
-                <a:ea typeface="Calibri"/>
-                <a:cs typeface="Arial" panose="020B0604020202020204" pitchFamily="34" charset="0"/>
-                <a:sym typeface="Calibri"/>
-              </a:rPr>
-              <a:t>Keep your explanation precise and easy to understand</a:t>
-            </a:r>
-            <a:endParaRPr b="1" dirty="0">
-              <a:latin typeface="Arial" panose="020B0604020202020204" pitchFamily="34" charset="0"/>
-              <a:cs typeface="Arial" panose="020B0604020202020204" pitchFamily="34" charset="0"/>
-            </a:endParaRPr>
-          </a:p>
-          <a:p>
-            <a:pPr marL="514350" marR="0" lvl="0" indent="-514350" algn="just" rtl="0">
-              <a:lnSpc>
-                <a:spcPct val="90000"/>
-              </a:lnSpc>
-              <a:spcBef>
-                <a:spcPts val="1000"/>
-              </a:spcBef>
-              <a:spcAft>
-                <a:spcPts val="0"/>
-              </a:spcAft>
-              <a:buClr>
-                <a:schemeClr val="dk1"/>
-              </a:buClr>
-              <a:buSzPct val="100000"/>
-              <a:buFont typeface="Calibri"/>
-              <a:buAutoNum type="arabicPeriod"/>
-            </a:pPr>
-            <a:r>
-              <a:rPr lang="en-US" b="1" i="0" u="none" strike="noStrike" cap="none" dirty="0">
-                <a:solidFill>
-                  <a:schemeClr val="dk1"/>
-                </a:solidFill>
-                <a:latin typeface="Arial" panose="020B0604020202020204" pitchFamily="34" charset="0"/>
-                <a:ea typeface="Calibri"/>
-                <a:cs typeface="Arial" panose="020B0604020202020204" pitchFamily="34" charset="0"/>
-                <a:sym typeface="Calibri"/>
-              </a:rPr>
-              <a:t>Idea should be unique and novel. </a:t>
-            </a:r>
-            <a:endParaRPr b="1" dirty="0">
-              <a:latin typeface="Arial" panose="020B0604020202020204" pitchFamily="34" charset="0"/>
-              <a:cs typeface="Arial" panose="020B0604020202020204" pitchFamily="34" charset="0"/>
-            </a:endParaRPr>
-          </a:p>
-          <a:p>
-            <a:pPr marL="514350" marR="0" lvl="0" indent="-514350" algn="just" rtl="0">
-              <a:lnSpc>
-                <a:spcPct val="90000"/>
-              </a:lnSpc>
-              <a:spcBef>
-                <a:spcPts val="1000"/>
-              </a:spcBef>
-              <a:spcAft>
-                <a:spcPts val="0"/>
-              </a:spcAft>
-              <a:buClr>
-                <a:schemeClr val="dk1"/>
-              </a:buClr>
-              <a:buSzPct val="100000"/>
-              <a:buFont typeface="Calibri"/>
-              <a:buAutoNum type="arabicPeriod"/>
-            </a:pPr>
-            <a:r>
-              <a:rPr lang="en-US" b="1" i="0" u="none" strike="noStrike" cap="none" dirty="0">
-                <a:solidFill>
-                  <a:schemeClr val="dk1"/>
-                </a:solidFill>
-                <a:latin typeface="Arial" panose="020B0604020202020204" pitchFamily="34" charset="0"/>
-                <a:ea typeface="Calibri"/>
-                <a:cs typeface="Arial" panose="020B0604020202020204" pitchFamily="34" charset="0"/>
-                <a:sym typeface="Calibri"/>
-              </a:rPr>
-              <a:t>You can only use provided </a:t>
-            </a:r>
-            <a:r>
-              <a:rPr lang="en-US" b="1" dirty="0">
-                <a:solidFill>
-                  <a:schemeClr val="dk1"/>
-                </a:solidFill>
-                <a:latin typeface="Arial" panose="020B0604020202020204" pitchFamily="34" charset="0"/>
-                <a:ea typeface="Calibri"/>
-                <a:cs typeface="Arial" panose="020B0604020202020204" pitchFamily="34" charset="0"/>
-                <a:sym typeface="Calibri"/>
-              </a:rPr>
-              <a:t>template</a:t>
-            </a:r>
-            <a:r>
-              <a:rPr lang="en-US" b="1" i="0" u="none" strike="noStrike" cap="none" dirty="0">
-                <a:solidFill>
-                  <a:schemeClr val="dk1"/>
-                </a:solidFill>
-                <a:latin typeface="Arial" panose="020B0604020202020204" pitchFamily="34" charset="0"/>
-                <a:ea typeface="Calibri"/>
-                <a:cs typeface="Arial" panose="020B0604020202020204" pitchFamily="34" charset="0"/>
-                <a:sym typeface="Calibri"/>
-              </a:rPr>
-              <a:t> for making the </a:t>
-            </a:r>
-            <a:r>
-              <a:rPr lang="en-US" b="1" dirty="0">
-                <a:solidFill>
-                  <a:schemeClr val="dk1"/>
-                </a:solidFill>
-                <a:latin typeface="Arial" panose="020B0604020202020204" pitchFamily="34" charset="0"/>
-                <a:ea typeface="Calibri"/>
-                <a:cs typeface="Arial" panose="020B0604020202020204" pitchFamily="34" charset="0"/>
-                <a:sym typeface="Calibri"/>
-              </a:rPr>
-              <a:t>PPT</a:t>
-            </a:r>
-            <a:r>
-              <a:rPr lang="en-US" b="1" i="0" u="none" strike="noStrike" cap="none" dirty="0">
-                <a:solidFill>
-                  <a:schemeClr val="dk1"/>
-                </a:solidFill>
-                <a:latin typeface="Arial" panose="020B0604020202020204" pitchFamily="34" charset="0"/>
-                <a:ea typeface="Calibri"/>
-                <a:cs typeface="Arial" panose="020B0604020202020204" pitchFamily="34" charset="0"/>
-                <a:sym typeface="Calibri"/>
-              </a:rPr>
-              <a:t> without changing the idea details pointers (mentioned in previous slides).</a:t>
-            </a:r>
-            <a:endParaRPr b="1" i="0" u="none" strike="noStrike" cap="none" dirty="0">
-              <a:solidFill>
-                <a:schemeClr val="dk1"/>
-              </a:solidFill>
-              <a:latin typeface="Arial" panose="020B0604020202020204" pitchFamily="34" charset="0"/>
-              <a:ea typeface="Calibri"/>
-              <a:cs typeface="Arial" panose="020B0604020202020204" pitchFamily="34" charset="0"/>
-              <a:sym typeface="Calibri"/>
-            </a:endParaRPr>
-          </a:p>
-          <a:p>
-            <a:pPr marL="514350" marR="0" lvl="0" indent="-514350" algn="just" rtl="0">
-              <a:lnSpc>
-                <a:spcPct val="90000"/>
-              </a:lnSpc>
-              <a:spcBef>
-                <a:spcPts val="1000"/>
-              </a:spcBef>
-              <a:spcAft>
-                <a:spcPts val="0"/>
-              </a:spcAft>
-              <a:buClr>
-                <a:schemeClr val="dk1"/>
-              </a:buClr>
-              <a:buSzPct val="100000"/>
-              <a:buFont typeface="Calibri"/>
-              <a:buAutoNum type="arabicPeriod"/>
-            </a:pPr>
-            <a:r>
-              <a:rPr lang="en-US" b="1" i="0" u="none" strike="noStrike" cap="none" dirty="0">
-                <a:solidFill>
-                  <a:schemeClr val="dk1"/>
-                </a:solidFill>
-                <a:latin typeface="Arial" panose="020B0604020202020204" pitchFamily="34" charset="0"/>
-                <a:ea typeface="Calibri"/>
-                <a:cs typeface="Arial" panose="020B0604020202020204" pitchFamily="34" charset="0"/>
-                <a:sym typeface="Calibri"/>
-              </a:rPr>
-              <a:t>You need to save the file in PDF and upload the same on portal. No PPT, Word Doc or any other format will be supported.</a:t>
-            </a:r>
-            <a:endParaRPr b="1" dirty="0">
-              <a:latin typeface="Arial" panose="020B0604020202020204" pitchFamily="34" charset="0"/>
-              <a:cs typeface="Arial" panose="020B0604020202020204" pitchFamily="34" charset="0"/>
-            </a:endParaRPr>
-          </a:p>
-          <a:p>
-            <a:pPr marL="514350" marR="0" lvl="0" indent="-349885" algn="just" rtl="0">
-              <a:lnSpc>
-                <a:spcPct val="90000"/>
-              </a:lnSpc>
-              <a:spcBef>
-                <a:spcPts val="1000"/>
-              </a:spcBef>
-              <a:spcAft>
-                <a:spcPts val="0"/>
-              </a:spcAft>
-              <a:buClr>
-                <a:schemeClr val="dk1"/>
-              </a:buClr>
-              <a:buSzPct val="100000"/>
-              <a:buFont typeface="Calibri"/>
-              <a:buNone/>
-            </a:pPr>
-            <a:endParaRPr b="1" i="0" u="none" strike="noStrike" cap="none" dirty="0">
-              <a:solidFill>
-                <a:schemeClr val="dk1"/>
-              </a:solidFill>
-              <a:latin typeface="Arial" panose="020B0604020202020204" pitchFamily="34" charset="0"/>
-              <a:ea typeface="Calibri"/>
-              <a:cs typeface="Arial" panose="020B0604020202020204" pitchFamily="34" charset="0"/>
-              <a:sym typeface="Calibri"/>
-            </a:endParaRPr>
-          </a:p>
-          <a:p>
-            <a:pPr marL="0" marR="0" lvl="0" indent="0" algn="just" rtl="0">
-              <a:lnSpc>
-                <a:spcPct val="90000"/>
-              </a:lnSpc>
-              <a:spcBef>
-                <a:spcPts val="1000"/>
-              </a:spcBef>
-              <a:spcAft>
-                <a:spcPts val="0"/>
-              </a:spcAft>
-              <a:buClr>
-                <a:schemeClr val="dk1"/>
-              </a:buClr>
-              <a:buSzPct val="100000"/>
-              <a:buFont typeface="Arial"/>
-              <a:buNone/>
-            </a:pPr>
-            <a:r>
-              <a:rPr lang="en-US" b="1" i="0" u="none" strike="noStrike" cap="none" dirty="0">
-                <a:solidFill>
-                  <a:srgbClr val="C00000"/>
-                </a:solidFill>
-                <a:latin typeface="Arial" panose="020B0604020202020204" pitchFamily="34" charset="0"/>
-                <a:ea typeface="Calibri"/>
-                <a:cs typeface="Arial" panose="020B0604020202020204" pitchFamily="34" charset="0"/>
-                <a:sym typeface="Calibri"/>
-              </a:rPr>
-              <a:t>Note - You can delete this slide (Important Pointers) when you upload the details of your idea on SIH portal.</a:t>
-            </a:r>
-            <a:endParaRPr b="1" dirty="0">
-              <a:solidFill>
-                <a:srgbClr val="C00000"/>
-              </a:solidFill>
-              <a:latin typeface="Arial" panose="020B0604020202020204" pitchFamily="34" charset="0"/>
-              <a:cs typeface="Arial" panose="020B0604020202020204" pitchFamily="34" charset="0"/>
-            </a:endParaRPr>
-          </a:p>
-          <a:p>
-            <a:pPr marL="914400" marR="0" lvl="1" indent="-316230" algn="just" rtl="0">
-              <a:lnSpc>
-                <a:spcPct val="90000"/>
-              </a:lnSpc>
-              <a:spcBef>
-                <a:spcPts val="500"/>
-              </a:spcBef>
-              <a:spcAft>
-                <a:spcPts val="0"/>
-              </a:spcAft>
-              <a:buClr>
-                <a:schemeClr val="dk1"/>
-              </a:buClr>
-              <a:buSzPct val="100000"/>
-              <a:buFont typeface="Calibri"/>
-              <a:buNone/>
-            </a:pPr>
-            <a:endParaRPr sz="2000" b="1" i="0" u="none" strike="noStrike" cap="none" dirty="0">
-              <a:solidFill>
-                <a:schemeClr val="dk1"/>
-              </a:solidFill>
-              <a:latin typeface="Arial" panose="020B0604020202020204" pitchFamily="34" charset="0"/>
-              <a:ea typeface="Calibri"/>
-              <a:cs typeface="Arial" panose="020B0604020202020204" pitchFamily="34" charset="0"/>
-              <a:sym typeface="Calibri"/>
-            </a:endParaRPr>
-          </a:p>
-        </p:txBody>
-      </p:sp>
-      <p:sp>
-        <p:nvSpPr>
-          <p:cNvPr id="4" name="TextBox 3"/>
-          <p:cNvSpPr txBox="1"/>
-          <p:nvPr/>
-        </p:nvSpPr>
-        <p:spPr>
-          <a:xfrm>
-            <a:off x="1393371" y="107066"/>
-            <a:ext cx="8410540" cy="646331"/>
-          </a:xfrm>
-          <a:prstGeom prst="rect">
-            <a:avLst/>
-          </a:prstGeom>
-          <a:noFill/>
-        </p:spPr>
-        <p:txBody>
-          <a:bodyPr wrap="square" rtlCol="0">
-            <a:spAutoFit/>
-          </a:bodyPr>
-          <a:lstStyle/>
-          <a:p>
-            <a:pPr algn="ctr"/>
-            <a:r>
-              <a:rPr lang="en-US" sz="3600" b="1" dirty="0">
-                <a:latin typeface="Times New Roman" panose="02020603050405020304" pitchFamily="18" charset="0"/>
-                <a:cs typeface="Times New Roman" panose="02020603050405020304" pitchFamily="18" charset="0"/>
-              </a:rPr>
-              <a:t>IMPORTANT INSTRUCTIONS</a:t>
-            </a:r>
-            <a:endParaRPr lang="en-IN" sz="3600" b="1" dirty="0">
-              <a:latin typeface="Times New Roman" panose="02020603050405020304" pitchFamily="18" charset="0"/>
-              <a:cs typeface="Times New Roman" panose="02020603050405020304" pitchFamily="18" charset="0"/>
-            </a:endParaRPr>
-          </a:p>
-        </p:txBody>
-      </p:sp>
-      <p:sp>
-        <p:nvSpPr>
-          <p:cNvPr id="5" name="TextBox 4"/>
-          <p:cNvSpPr txBox="1"/>
-          <p:nvPr/>
-        </p:nvSpPr>
-        <p:spPr>
-          <a:xfrm>
-            <a:off x="602343" y="1181900"/>
-            <a:ext cx="9557657" cy="341632"/>
-          </a:xfrm>
-          <a:prstGeom prst="rect">
-            <a:avLst/>
-          </a:prstGeom>
-          <a:noFill/>
-        </p:spPr>
-        <p:txBody>
-          <a:bodyPr wrap="square" rtlCol="0">
-            <a:spAutoFit/>
-          </a:bodyPr>
-          <a:lstStyle/>
-          <a:p>
-            <a:pPr algn="just">
-              <a:lnSpc>
-                <a:spcPct val="90000"/>
-              </a:lnSpc>
-              <a:spcBef>
-                <a:spcPts val="1000"/>
-              </a:spcBef>
-              <a:spcAft>
-                <a:spcPts val="0"/>
-              </a:spcAft>
-              <a:buClr>
-                <a:schemeClr val="dk1"/>
-              </a:buClr>
-              <a:buSzPct val="100000"/>
-            </a:pPr>
-            <a:r>
-              <a:rPr lang="en-US" b="1" dirty="0">
-                <a:solidFill>
-                  <a:schemeClr val="dk1"/>
-                </a:solidFill>
-                <a:latin typeface="Arial" panose="020B0604020202020204" pitchFamily="34" charset="0"/>
-                <a:ea typeface="Calibri"/>
-                <a:cs typeface="Arial" panose="020B0604020202020204" pitchFamily="34" charset="0"/>
-              </a:rPr>
-              <a:t>Please ensure below pointers are met while submitting the Idea PPT:</a:t>
-            </a:r>
-            <a:endParaRPr lang="en-IN" b="1" dirty="0">
-              <a:solidFill>
-                <a:schemeClr val="dk1"/>
-              </a:solidFill>
-              <a:latin typeface="Arial" panose="020B0604020202020204" pitchFamily="34" charset="0"/>
-              <a:ea typeface="Calibri"/>
-              <a:cs typeface="Arial" panose="020B0604020202020204" pitchFamily="34" charset="0"/>
-            </a:endParaRPr>
-          </a:p>
-        </p:txBody>
-      </p:sp>
-      <p:pic>
-        <p:nvPicPr>
-          <p:cNvPr id="13" name="Picture 12"/>
-          <p:cNvPicPr>
-            <a:picLocks noChangeAspect="1"/>
-          </p:cNvPicPr>
-          <p:nvPr/>
-        </p:nvPicPr>
-        <p:blipFill>
-          <a:blip r:embed="rId3">
-            <a:extLst>
-              <a:ext uri="{28A0092B-C50C-407E-A947-70E740481C1C}">
-                <a14:useLocalDpi xmlns:a14="http://schemas.microsoft.com/office/drawing/2010/main" val="0"/>
-              </a:ext>
-            </a:extLst>
-          </a:blip>
-          <a:stretch>
-            <a:fillRect/>
-          </a:stretch>
-        </p:blipFill>
-        <p:spPr>
-          <a:xfrm>
-            <a:off x="9780086" y="1500"/>
-            <a:ext cx="2249850" cy="1062337"/>
-          </a:xfrm>
-          <a:prstGeom prst="rect">
-            <a:avLst/>
-          </a:prstGeom>
-        </p:spPr>
-      </p:pic>
-    </p:spTree>
-    <p:extLst>
-      <p:ext uri="{BB962C8B-B14F-4D97-AF65-F5344CB8AC3E}">
-        <p14:creationId xmlns:p14="http://schemas.microsoft.com/office/powerpoint/2010/main" val="1588084416"/>
       </p:ext>
     </p:extLst>
   </p:cSld>

</xml_diff>